<commit_message>
Fix shapes in PPTX script and re-generate clean slides
</commit_message>
<xml_diff>
--- a/API_Marketplace_Presentation.pptx
+++ b/API_Marketplace_Presentation.pptx
@@ -1302,7 +1302,7 @@
     <p:bg>
       <p:bgPr>
         <a:solidFill>
-          <a:srgbClr val="0D0D0D"/>
+          <a:srgbClr val="080808"/>
         </a:solidFill>
       </p:bgPr>
     </p:bg>
@@ -1322,14 +1322,34 @@
       </p:grpSpPr>
       <p:sp>
         <p:nvSpPr>
-          <p:cNvPr id="2" name="Text 0"/>
+          <p:cNvPr id="2" name="Shape 0"/>
           <p:cNvSpPr/>
           <p:nvPr/>
         </p:nvSpPr>
         <p:spPr>
           <a:xfrm>
             <a:off x="914400" y="1828800"/>
-            <a:ext cx="10360152" cy="4114800"/>
+            <a:ext cx="91440" cy="3200400"/>
+          </a:xfrm>
+          <a:prstGeom prst="rect">
+            <a:avLst/>
+          </a:prstGeom>
+          <a:solidFill>
+            <a:srgbClr val="00F3FF"/>
+          </a:solidFill>
+          <a:ln/>
+        </p:spPr>
+      </p:sp>
+      <p:sp>
+        <p:nvSpPr>
+          <p:cNvPr id="3" name="Text 1"/>
+          <p:cNvSpPr/>
+          <p:nvPr/>
+        </p:nvSpPr>
+        <p:spPr>
+          <a:xfrm>
+            <a:off x="1188720" y="1828800"/>
+            <a:ext cx="10058400" cy="3200400"/>
           </a:xfrm>
           <a:prstGeom prst="rect">
             <a:avLst/>
@@ -1345,7 +1365,7 @@
               <a:buNone/>
             </a:pPr>
             <a:r>
-              <a:rPr lang="en-US" sz="6400" b="1" dirty="0">
+              <a:rPr lang="en-US" sz="6000" b="1" dirty="0">
                 <a:solidFill>
                   <a:srgbClr val="00F3FF"/>
                 </a:solidFill>
@@ -1360,7 +1380,7 @@
               <a:buNone/>
             </a:pPr>
             <a:r>
-              <a:rPr lang="en-US" sz="2400" dirty="0">
+              <a:rPr lang="en-US" sz="2000" dirty="0">
                 <a:solidFill>
                   <a:srgbClr val="FFFFFF"/>
                 </a:solidFill>
@@ -1368,14 +1388,14 @@
                 <a:ea typeface="Inter" pitchFamily="34" charset="-122"/>
                 <a:cs typeface="Inter" pitchFamily="34" charset="-120"/>
               </a:rPr>
-              <a:t>A Scalable, Unified API Marketplace &amp; Gateway Platform
+              <a:t>A Unified Open-Source API Marketplace &amp; Gateway
 </a:t>
             </a:r>
             <a:pPr indent="0" marL="0">
               <a:buNone/>
             </a:pPr>
             <a:r>
-              <a:rPr lang="en-US" sz="1800" b="1" dirty="0">
+              <a:rPr lang="en-US" sz="1400" b="1" dirty="0">
                 <a:solidFill>
                   <a:srgbClr val="FFFFFF"/>
                 </a:solidFill>
@@ -1390,17 +1410,17 @@
               <a:buNone/>
             </a:pPr>
             <a:r>
-              <a:rPr lang="en-US" sz="1400" dirty="0">
-                <a:solidFill>
-                  <a:srgbClr val="AAAAAA"/>
+              <a:rPr lang="en-US" sz="1200" dirty="0">
+                <a:solidFill>
+                  <a:srgbClr val="A0A0A0"/>
                 </a:solidFill>
                 <a:latin typeface="Inter" pitchFamily="34" charset="0"/>
                 <a:ea typeface="Inter" pitchFamily="34" charset="-122"/>
                 <a:cs typeface="Inter" pitchFamily="34" charset="-120"/>
               </a:rPr>
-              <a:t>B.Tech CSE (AI) | Parul University | github.com/Karthhikk18</a:t>
-            </a:r>
-            <a:endParaRPr lang="en-US" sz="6400" dirty="0"/>
+              <a:t>B.Tech CSE (AI) | github.com/Karthhikk18</a:t>
+            </a:r>
+            <a:endParaRPr lang="en-US" sz="6000" dirty="0"/>
           </a:p>
         </p:txBody>
       </p:sp>
@@ -1418,7 +1438,7 @@
     <p:bg>
       <p:bgPr>
         <a:solidFill>
-          <a:srgbClr val="0D0D0D"/>
+          <a:srgbClr val="080808"/>
         </a:solidFill>
       </p:bgPr>
     </p:bg>
@@ -1444,7 +1464,7 @@
         </p:nvSpPr>
         <p:spPr>
           <a:xfrm>
-            <a:off x="914400" y="548640"/>
+            <a:off x="914400" y="457200"/>
             <a:ext cx="10360152" cy="731520"/>
           </a:xfrm>
           <a:prstGeom prst="rect">
@@ -1461,7 +1481,7 @@
               <a:buNone/>
             </a:pPr>
             <a:r>
-              <a:rPr lang="en-US" sz="3600" b="1" dirty="0">
+              <a:rPr lang="en-US" sz="3200" b="1" dirty="0">
                 <a:solidFill>
                   <a:srgbClr val="00F3FF"/>
                 </a:solidFill>
@@ -1471,20 +1491,65 @@
               </a:rPr>
               <a:t>The Problem</a:t>
             </a:r>
-            <a:endParaRPr lang="en-US" sz="3600" dirty="0"/>
-          </a:p>
-        </p:txBody>
-      </p:sp>
-      <p:sp>
-        <p:nvSpPr>
-          <p:cNvPr id="3" name="Text 1"/>
+            <a:endParaRPr lang="en-US" sz="3200" dirty="0"/>
+          </a:p>
+        </p:txBody>
+      </p:sp>
+      <p:sp>
+        <p:nvSpPr>
+          <p:cNvPr id="3" name="Shape 1"/>
+          <p:cNvSpPr/>
+          <p:nvPr/>
+        </p:nvSpPr>
+        <p:spPr>
+          <a:xfrm>
+            <a:off x="914400" y="1143000"/>
+            <a:ext cx="1828800" cy="36576"/>
+          </a:xfrm>
+          <a:prstGeom prst="rect">
+            <a:avLst/>
+          </a:prstGeom>
+          <a:solidFill>
+            <a:srgbClr val="00F3FF"/>
+          </a:solidFill>
+          <a:ln/>
+        </p:spPr>
+      </p:sp>
+      <p:sp>
+        <p:nvSpPr>
+          <p:cNvPr id="4" name="Shape 2"/>
           <p:cNvSpPr/>
           <p:nvPr/>
         </p:nvSpPr>
         <p:spPr>
           <a:xfrm>
             <a:off x="914400" y="1645920"/>
-            <a:ext cx="10360152" cy="4572000"/>
+            <a:ext cx="4937760" cy="2103120"/>
+          </a:xfrm>
+          <a:prstGeom prst="roundRect">
+            <a:avLst/>
+          </a:prstGeom>
+          <a:solidFill>
+            <a:srgbClr val="121212"/>
+          </a:solidFill>
+          <a:ln w="12700">
+            <a:solidFill>
+              <a:srgbClr val="222222"/>
+            </a:solidFill>
+            <a:prstDash val="solid"/>
+          </a:ln>
+        </p:spPr>
+      </p:sp>
+      <p:sp>
+        <p:nvSpPr>
+          <p:cNvPr id="5" name="Text 3"/>
+          <p:cNvSpPr/>
+          <p:nvPr/>
+        </p:nvSpPr>
+        <p:spPr>
+          <a:xfrm>
+            <a:off x="1143000" y="1828800"/>
+            <a:ext cx="4480560" cy="365760"/>
           </a:xfrm>
           <a:prstGeom prst="rect">
             <a:avLst/>
@@ -1502,116 +1567,363 @@
             <a:r>
               <a:rPr lang="en-US" sz="1600" b="1" dirty="0">
                 <a:solidFill>
-                  <a:srgbClr val="FFFFFF"/>
+                  <a:srgbClr val="00F3FF"/>
+                </a:solidFill>
+                <a:latin typeface="Outfit" pitchFamily="34" charset="0"/>
+                <a:ea typeface="Outfit" pitchFamily="34" charset="-122"/>
+                <a:cs typeface="Outfit" pitchFamily="34" charset="-120"/>
+              </a:rPr>
+              <a:t>01 / Fragmentation of Tools</a:t>
+            </a:r>
+            <a:endParaRPr lang="en-US" sz="1600" dirty="0"/>
+          </a:p>
+        </p:txBody>
+      </p:sp>
+      <p:sp>
+        <p:nvSpPr>
+          <p:cNvPr id="6" name="Text 4"/>
+          <p:cNvSpPr/>
+          <p:nvPr/>
+        </p:nvSpPr>
+        <p:spPr>
+          <a:xfrm>
+            <a:off x="1143000" y="2286000"/>
+            <a:ext cx="4480560" cy="1280160"/>
+          </a:xfrm>
+          <a:prstGeom prst="rect">
+            <a:avLst/>
+          </a:prstGeom>
+          <a:noFill/>
+          <a:ln/>
+        </p:spPr>
+        <p:txBody>
+          <a:bodyPr wrap="square" rtlCol="0" anchor="t"/>
+          <a:lstStyle/>
+          <a:p>
+            <a:pPr indent="0" marL="0">
+              <a:buNone/>
+            </a:pPr>
+            <a:r>
+              <a:rPr lang="en-US" sz="1300" dirty="0">
+                <a:solidFill>
+                  <a:srgbClr val="A0A0A0"/>
                 </a:solidFill>
                 <a:latin typeface="Inter" pitchFamily="34" charset="0"/>
                 <a:ea typeface="Inter" pitchFamily="34" charset="-122"/>
                 <a:cs typeface="Inter" pitchFamily="34" charset="-120"/>
               </a:rPr>
-              <a:t>▪  Fragmentation of Tools: </a:t>
-            </a:r>
-            <a:pPr indent="0" marL="0">
-              <a:buNone/>
-            </a:pPr>
-            <a:r>
-              <a:rPr lang="en-US" sz="1600" dirty="0">
-                <a:solidFill>
-                  <a:srgbClr val="AAAAAA"/>
+              <a:t>Developers waste hours searching, subscribing, and evaluating API tools across multiple scattered providers.</a:t>
+            </a:r>
+            <a:endParaRPr lang="en-US" sz="1300" dirty="0"/>
+          </a:p>
+        </p:txBody>
+      </p:sp>
+      <p:sp>
+        <p:nvSpPr>
+          <p:cNvPr id="7" name="Shape 5"/>
+          <p:cNvSpPr/>
+          <p:nvPr/>
+        </p:nvSpPr>
+        <p:spPr>
+          <a:xfrm>
+            <a:off x="6336792" y="1645920"/>
+            <a:ext cx="4937760" cy="2103120"/>
+          </a:xfrm>
+          <a:prstGeom prst="roundRect">
+            <a:avLst/>
+          </a:prstGeom>
+          <a:solidFill>
+            <a:srgbClr val="121212"/>
+          </a:solidFill>
+          <a:ln w="12700">
+            <a:solidFill>
+              <a:srgbClr val="222222"/>
+            </a:solidFill>
+            <a:prstDash val="solid"/>
+          </a:ln>
+        </p:spPr>
+      </p:sp>
+      <p:sp>
+        <p:nvSpPr>
+          <p:cNvPr id="8" name="Text 6"/>
+          <p:cNvSpPr/>
+          <p:nvPr/>
+        </p:nvSpPr>
+        <p:spPr>
+          <a:xfrm>
+            <a:off x="6565392" y="1828800"/>
+            <a:ext cx="4480560" cy="365760"/>
+          </a:xfrm>
+          <a:prstGeom prst="rect">
+            <a:avLst/>
+          </a:prstGeom>
+          <a:noFill/>
+          <a:ln/>
+        </p:spPr>
+        <p:txBody>
+          <a:bodyPr wrap="square" rtlCol="0" anchor="ctr"/>
+          <a:lstStyle/>
+          <a:p>
+            <a:pPr indent="0" marL="0">
+              <a:buNone/>
+            </a:pPr>
+            <a:r>
+              <a:rPr lang="en-US" sz="1600" b="1" dirty="0">
+                <a:solidFill>
+                  <a:srgbClr val="00F3FF"/>
+                </a:solidFill>
+                <a:latin typeface="Outfit" pitchFamily="34" charset="0"/>
+                <a:ea typeface="Outfit" pitchFamily="34" charset="-122"/>
+                <a:cs typeface="Outfit" pitchFamily="34" charset="-120"/>
+              </a:rPr>
+              <a:t>02 / Integration Hurdles</a:t>
+            </a:r>
+            <a:endParaRPr lang="en-US" sz="1600" dirty="0"/>
+          </a:p>
+        </p:txBody>
+      </p:sp>
+      <p:sp>
+        <p:nvSpPr>
+          <p:cNvPr id="9" name="Text 7"/>
+          <p:cNvSpPr/>
+          <p:nvPr/>
+        </p:nvSpPr>
+        <p:spPr>
+          <a:xfrm>
+            <a:off x="6565392" y="2286000"/>
+            <a:ext cx="4480560" cy="1280160"/>
+          </a:xfrm>
+          <a:prstGeom prst="rect">
+            <a:avLst/>
+          </a:prstGeom>
+          <a:noFill/>
+          <a:ln/>
+        </p:spPr>
+        <p:txBody>
+          <a:bodyPr wrap="square" rtlCol="0" anchor="t"/>
+          <a:lstStyle/>
+          <a:p>
+            <a:pPr indent="0" marL="0">
+              <a:buNone/>
+            </a:pPr>
+            <a:r>
+              <a:rPr lang="en-US" sz="1300" dirty="0">
+                <a:solidFill>
+                  <a:srgbClr val="A0A0A0"/>
                 </a:solidFill>
                 <a:latin typeface="Inter" pitchFamily="34" charset="0"/>
                 <a:ea typeface="Inter" pitchFamily="34" charset="-122"/>
                 <a:cs typeface="Inter" pitchFamily="34" charset="-120"/>
               </a:rPr>
-              <a:t>Developers waste valuable time searching and evaluating APIs scattered across dozens of individual portals.
-</a:t>
-            </a:r>
+              <a:t>Testing endpoints is restricted by paid subscription tiers, forced registrations, or complex client SDK setup scripts.</a:t>
+            </a:r>
+            <a:endParaRPr lang="en-US" sz="1300" dirty="0"/>
+          </a:p>
+        </p:txBody>
+      </p:sp>
+      <p:sp>
+        <p:nvSpPr>
+          <p:cNvPr id="10" name="Shape 8"/>
+          <p:cNvSpPr/>
+          <p:nvPr/>
+        </p:nvSpPr>
+        <p:spPr>
+          <a:xfrm>
+            <a:off x="914400" y="4114800"/>
+            <a:ext cx="4937760" cy="2103120"/>
+          </a:xfrm>
+          <a:prstGeom prst="roundRect">
+            <a:avLst/>
+          </a:prstGeom>
+          <a:solidFill>
+            <a:srgbClr val="121212"/>
+          </a:solidFill>
+          <a:ln w="12700">
+            <a:solidFill>
+              <a:srgbClr val="222222"/>
+            </a:solidFill>
+            <a:prstDash val="solid"/>
+          </a:ln>
+        </p:spPr>
+      </p:sp>
+      <p:sp>
+        <p:nvSpPr>
+          <p:cNvPr id="11" name="Text 9"/>
+          <p:cNvSpPr/>
+          <p:nvPr/>
+        </p:nvSpPr>
+        <p:spPr>
+          <a:xfrm>
+            <a:off x="1143000" y="4297680"/>
+            <a:ext cx="4480560" cy="365760"/>
+          </a:xfrm>
+          <a:prstGeom prst="rect">
+            <a:avLst/>
+          </a:prstGeom>
+          <a:noFill/>
+          <a:ln/>
+        </p:spPr>
+        <p:txBody>
+          <a:bodyPr wrap="square" rtlCol="0" anchor="ctr"/>
+          <a:lstStyle/>
+          <a:p>
             <a:pPr indent="0" marL="0">
               <a:buNone/>
             </a:pPr>
             <a:r>
               <a:rPr lang="en-US" sz="1600" b="1" dirty="0">
                 <a:solidFill>
-                  <a:srgbClr val="FFFFFF"/>
+                  <a:srgbClr val="00F3FF"/>
+                </a:solidFill>
+                <a:latin typeface="Outfit" pitchFamily="34" charset="0"/>
+                <a:ea typeface="Outfit" pitchFamily="34" charset="-122"/>
+                <a:cs typeface="Outfit" pitchFamily="34" charset="-120"/>
+              </a:rPr>
+              <a:t>03 / Lack of Real-Time Sandbox</a:t>
+            </a:r>
+            <a:endParaRPr lang="en-US" sz="1600" dirty="0"/>
+          </a:p>
+        </p:txBody>
+      </p:sp>
+      <p:sp>
+        <p:nvSpPr>
+          <p:cNvPr id="12" name="Text 10"/>
+          <p:cNvSpPr/>
+          <p:nvPr/>
+        </p:nvSpPr>
+        <p:spPr>
+          <a:xfrm>
+            <a:off x="1143000" y="4754880"/>
+            <a:ext cx="4480560" cy="1280160"/>
+          </a:xfrm>
+          <a:prstGeom prst="rect">
+            <a:avLst/>
+          </a:prstGeom>
+          <a:noFill/>
+          <a:ln/>
+        </p:spPr>
+        <p:txBody>
+          <a:bodyPr wrap="square" rtlCol="0" anchor="t"/>
+          <a:lstStyle/>
+          <a:p>
+            <a:pPr indent="0" marL="0">
+              <a:buNone/>
+            </a:pPr>
+            <a:r>
+              <a:rPr lang="en-US" sz="1300" dirty="0">
+                <a:solidFill>
+                  <a:srgbClr val="A0A0A0"/>
                 </a:solidFill>
                 <a:latin typeface="Inter" pitchFamily="34" charset="0"/>
                 <a:ea typeface="Inter" pitchFamily="34" charset="-122"/>
                 <a:cs typeface="Inter" pitchFamily="34" charset="-120"/>
               </a:rPr>
-              <a:t>▪  Integration Bottlenecks: </a:t>
-            </a:r>
-            <a:pPr indent="0" marL="0">
-              <a:buNone/>
-            </a:pPr>
-            <a:r>
-              <a:rPr lang="en-US" sz="1600" dirty="0">
-                <a:solidFill>
-                  <a:srgbClr val="AAAAAA"/>
+              <a:t>No immediate feedback loop to inspect response schemas directly in the browser, forcing developers to code custom test environments.</a:t>
+            </a:r>
+            <a:endParaRPr lang="en-US" sz="1300" dirty="0"/>
+          </a:p>
+        </p:txBody>
+      </p:sp>
+      <p:sp>
+        <p:nvSpPr>
+          <p:cNvPr id="13" name="Shape 11"/>
+          <p:cNvSpPr/>
+          <p:nvPr/>
+        </p:nvSpPr>
+        <p:spPr>
+          <a:xfrm>
+            <a:off x="6336792" y="4114800"/>
+            <a:ext cx="4937760" cy="2103120"/>
+          </a:xfrm>
+          <a:prstGeom prst="roundRect">
+            <a:avLst/>
+          </a:prstGeom>
+          <a:solidFill>
+            <a:srgbClr val="121212"/>
+          </a:solidFill>
+          <a:ln w="12700">
+            <a:solidFill>
+              <a:srgbClr val="222222"/>
+            </a:solidFill>
+            <a:prstDash val="solid"/>
+          </a:ln>
+        </p:spPr>
+      </p:sp>
+      <p:sp>
+        <p:nvSpPr>
+          <p:cNvPr id="14" name="Text 12"/>
+          <p:cNvSpPr/>
+          <p:nvPr/>
+        </p:nvSpPr>
+        <p:spPr>
+          <a:xfrm>
+            <a:off x="6565392" y="4297680"/>
+            <a:ext cx="4480560" cy="365760"/>
+          </a:xfrm>
+          <a:prstGeom prst="rect">
+            <a:avLst/>
+          </a:prstGeom>
+          <a:noFill/>
+          <a:ln/>
+        </p:spPr>
+        <p:txBody>
+          <a:bodyPr wrap="square" rtlCol="0" anchor="ctr"/>
+          <a:lstStyle/>
+          <a:p>
+            <a:pPr indent="0" marL="0">
+              <a:buNone/>
+            </a:pPr>
+            <a:r>
+              <a:rPr lang="en-US" sz="1600" b="1" dirty="0">
+                <a:solidFill>
+                  <a:srgbClr val="00F3FF"/>
+                </a:solidFill>
+                <a:latin typeface="Outfit" pitchFamily="34" charset="0"/>
+                <a:ea typeface="Outfit" pitchFamily="34" charset="-122"/>
+                <a:cs typeface="Outfit" pitchFamily="34" charset="-120"/>
+              </a:rPr>
+              <a:t>04 / Gateway Engineering Complexity</a:t>
+            </a:r>
+            <a:endParaRPr lang="en-US" sz="1600" dirty="0"/>
+          </a:p>
+        </p:txBody>
+      </p:sp>
+      <p:sp>
+        <p:nvSpPr>
+          <p:cNvPr id="15" name="Text 13"/>
+          <p:cNvSpPr/>
+          <p:nvPr/>
+        </p:nvSpPr>
+        <p:spPr>
+          <a:xfrm>
+            <a:off x="6565392" y="4754880"/>
+            <a:ext cx="4480560" cy="1280160"/>
+          </a:xfrm>
+          <a:prstGeom prst="rect">
+            <a:avLst/>
+          </a:prstGeom>
+          <a:noFill/>
+          <a:ln/>
+        </p:spPr>
+        <p:txBody>
+          <a:bodyPr wrap="square" rtlCol="0" anchor="t"/>
+          <a:lstStyle/>
+          <a:p>
+            <a:pPr indent="0" marL="0">
+              <a:buNone/>
+            </a:pPr>
+            <a:r>
+              <a:rPr lang="en-US" sz="1300" dirty="0">
+                <a:solidFill>
+                  <a:srgbClr val="A0A0A0"/>
                 </a:solidFill>
                 <a:latin typeface="Inter" pitchFamily="34" charset="0"/>
                 <a:ea typeface="Inter" pitchFamily="34" charset="-122"/>
                 <a:cs typeface="Inter" pitchFamily="34" charset="-120"/>
               </a:rPr>
-              <a:t>Simple prototyping is hindered by required logins, API key subscriptions, or complex setup scripts.
-</a:t>
-            </a:r>
-            <a:pPr indent="0" marL="0">
-              <a:buNone/>
-            </a:pPr>
-            <a:r>
-              <a:rPr lang="en-US" sz="1600" b="1" dirty="0">
-                <a:solidFill>
-                  <a:srgbClr val="FFFFFF"/>
-                </a:solidFill>
-                <a:latin typeface="Inter" pitchFamily="34" charset="0"/>
-                <a:ea typeface="Inter" pitchFamily="34" charset="-122"/>
-                <a:cs typeface="Inter" pitchFamily="34" charset="-120"/>
-              </a:rPr>
-              <a:t>▪  No Sandbox Environment: </a:t>
-            </a:r>
-            <a:pPr indent="0" marL="0">
-              <a:buNone/>
-            </a:pPr>
-            <a:r>
-              <a:rPr lang="en-US" sz="1600" dirty="0">
-                <a:solidFill>
-                  <a:srgbClr val="AAAAAA"/>
-                </a:solidFill>
-                <a:latin typeface="Inter" pitchFamily="34" charset="0"/>
-                <a:ea typeface="Inter" pitchFamily="34" charset="-122"/>
-                <a:cs typeface="Inter" pitchFamily="34" charset="-120"/>
-              </a:rPr>
-              <a:t>Testing response structures typically forces developers to write dummy backend queries rather than running quick sandbox requests.
-</a:t>
-            </a:r>
-            <a:pPr indent="0" marL="0">
-              <a:buNone/>
-            </a:pPr>
-            <a:r>
-              <a:rPr lang="en-US" sz="1600" b="1" dirty="0">
-                <a:solidFill>
-                  <a:srgbClr val="FFFFFF"/>
-                </a:solidFill>
-                <a:latin typeface="Inter" pitchFamily="34" charset="0"/>
-                <a:ea typeface="Inter" pitchFamily="34" charset="-122"/>
-                <a:cs typeface="Inter" pitchFamily="34" charset="-120"/>
-              </a:rPr>
-              <a:t>▪  Complex Gateway Deployments: </a:t>
-            </a:r>
-            <a:pPr indent="0" marL="0">
-              <a:buNone/>
-            </a:pPr>
-            <a:r>
-              <a:rPr lang="en-US" sz="1600" dirty="0">
-                <a:solidFill>
-                  <a:srgbClr val="AAAAAA"/>
-                </a:solidFill>
-                <a:latin typeface="Inter" pitchFamily="34" charset="0"/>
-                <a:ea typeface="Inter" pitchFamily="34" charset="-122"/>
-                <a:cs typeface="Inter" pitchFamily="34" charset="-120"/>
-              </a:rPr>
-              <a:t>Designing systems that safely route requests, implement rate limiters, and track client API keys is a heavy engineering lift.</a:t>
-            </a:r>
-            <a:endParaRPr lang="en-US" sz="1600" dirty="0"/>
+              <a:t>Designing secure system gateways that safely manage authorization keys, handle rate limits, and record analytics calls is difficult.</a:t>
+            </a:r>
+            <a:endParaRPr lang="en-US" sz="1300" dirty="0"/>
           </a:p>
         </p:txBody>
       </p:sp>
@@ -1629,7 +1941,7 @@
     <p:bg>
       <p:bgPr>
         <a:solidFill>
-          <a:srgbClr val="0D0D0D"/>
+          <a:srgbClr val="080808"/>
         </a:solidFill>
       </p:bgPr>
     </p:bg>
@@ -1655,7 +1967,7 @@
         </p:nvSpPr>
         <p:spPr>
           <a:xfrm>
-            <a:off x="914400" y="548640"/>
+            <a:off x="914400" y="457200"/>
             <a:ext cx="10360152" cy="731520"/>
           </a:xfrm>
           <a:prstGeom prst="rect">
@@ -1672,7 +1984,7 @@
               <a:buNone/>
             </a:pPr>
             <a:r>
-              <a:rPr lang="en-US" sz="3600" b="1" dirty="0">
+              <a:rPr lang="en-US" sz="3200" b="1" dirty="0">
                 <a:solidFill>
                   <a:srgbClr val="00F3FF"/>
                 </a:solidFill>
@@ -1680,22 +1992,67 @@
                 <a:ea typeface="Outfit" pitchFamily="34" charset="-122"/>
                 <a:cs typeface="Outfit" pitchFamily="34" charset="-120"/>
               </a:rPr>
-              <a:t>The Solution: API Corner</a:t>
-            </a:r>
-            <a:endParaRPr lang="en-US" sz="3600" dirty="0"/>
-          </a:p>
-        </p:txBody>
-      </p:sp>
-      <p:sp>
-        <p:nvSpPr>
-          <p:cNvPr id="3" name="Text 1"/>
+              <a:t>The Solution</a:t>
+            </a:r>
+            <a:endParaRPr lang="en-US" sz="3200" dirty="0"/>
+          </a:p>
+        </p:txBody>
+      </p:sp>
+      <p:sp>
+        <p:nvSpPr>
+          <p:cNvPr id="3" name="Shape 1"/>
+          <p:cNvSpPr/>
+          <p:nvPr/>
+        </p:nvSpPr>
+        <p:spPr>
+          <a:xfrm>
+            <a:off x="914400" y="1143000"/>
+            <a:ext cx="1828800" cy="36576"/>
+          </a:xfrm>
+          <a:prstGeom prst="rect">
+            <a:avLst/>
+          </a:prstGeom>
+          <a:solidFill>
+            <a:srgbClr val="00F3FF"/>
+          </a:solidFill>
+          <a:ln/>
+        </p:spPr>
+      </p:sp>
+      <p:sp>
+        <p:nvSpPr>
+          <p:cNvPr id="4" name="Shape 2"/>
           <p:cNvSpPr/>
           <p:nvPr/>
         </p:nvSpPr>
         <p:spPr>
           <a:xfrm>
             <a:off x="914400" y="1645920"/>
-            <a:ext cx="10360152" cy="4572000"/>
+            <a:ext cx="4937760" cy="2103120"/>
+          </a:xfrm>
+          <a:prstGeom prst="roundRect">
+            <a:avLst/>
+          </a:prstGeom>
+          <a:solidFill>
+            <a:srgbClr val="121212"/>
+          </a:solidFill>
+          <a:ln w="12700">
+            <a:solidFill>
+              <a:srgbClr val="222222"/>
+            </a:solidFill>
+            <a:prstDash val="solid"/>
+          </a:ln>
+        </p:spPr>
+      </p:sp>
+      <p:sp>
+        <p:nvSpPr>
+          <p:cNvPr id="5" name="Text 3"/>
+          <p:cNvSpPr/>
+          <p:nvPr/>
+        </p:nvSpPr>
+        <p:spPr>
+          <a:xfrm>
+            <a:off x="1143000" y="1828800"/>
+            <a:ext cx="4480560" cy="365760"/>
           </a:xfrm>
           <a:prstGeom prst="rect">
             <a:avLst/>
@@ -1713,116 +2070,363 @@
             <a:r>
               <a:rPr lang="en-US" sz="1600" b="1" dirty="0">
                 <a:solidFill>
-                  <a:srgbClr val="FFFFFF"/>
+                  <a:srgbClr val="00F3FF"/>
+                </a:solidFill>
+                <a:latin typeface="Outfit" pitchFamily="34" charset="0"/>
+                <a:ea typeface="Outfit" pitchFamily="34" charset="-122"/>
+                <a:cs typeface="Outfit" pitchFamily="34" charset="-120"/>
+              </a:rPr>
+              <a:t>01 / Centralized API Directory</a:t>
+            </a:r>
+            <a:endParaRPr lang="en-US" sz="1600" dirty="0"/>
+          </a:p>
+        </p:txBody>
+      </p:sp>
+      <p:sp>
+        <p:nvSpPr>
+          <p:cNvPr id="6" name="Text 4"/>
+          <p:cNvSpPr/>
+          <p:nvPr/>
+        </p:nvSpPr>
+        <p:spPr>
+          <a:xfrm>
+            <a:off x="1143000" y="2286000"/>
+            <a:ext cx="4480560" cy="1280160"/>
+          </a:xfrm>
+          <a:prstGeom prst="rect">
+            <a:avLst/>
+          </a:prstGeom>
+          <a:noFill/>
+          <a:ln/>
+        </p:spPr>
+        <p:txBody>
+          <a:bodyPr wrap="square" rtlCol="0" anchor="t"/>
+          <a:lstStyle/>
+          <a:p>
+            <a:pPr indent="0" marL="0">
+              <a:buNone/>
+            </a:pPr>
+            <a:r>
+              <a:rPr lang="en-US" sz="1300" dirty="0">
+                <a:solidFill>
+                  <a:srgbClr val="A0A0A0"/>
                 </a:solidFill>
                 <a:latin typeface="Inter" pitchFamily="34" charset="0"/>
                 <a:ea typeface="Inter" pitchFamily="34" charset="-122"/>
                 <a:cs typeface="Inter" pitchFamily="34" charset="-120"/>
               </a:rPr>
-              <a:t>▪  Unified API Directory: </a:t>
-            </a:r>
-            <a:pPr indent="0" marL="0">
-              <a:buNone/>
-            </a:pPr>
-            <a:r>
-              <a:rPr lang="en-US" sz="1600" dirty="0">
-                <a:solidFill>
-                  <a:srgbClr val="AAAAAA"/>
+              <a:t>A structured, premium catalog exposing diverse APIs from machine learning performance analyzers to blockchain wallets.</a:t>
+            </a:r>
+            <a:endParaRPr lang="en-US" sz="1300" dirty="0"/>
+          </a:p>
+        </p:txBody>
+      </p:sp>
+      <p:sp>
+        <p:nvSpPr>
+          <p:cNvPr id="7" name="Shape 5"/>
+          <p:cNvSpPr/>
+          <p:nvPr/>
+        </p:nvSpPr>
+        <p:spPr>
+          <a:xfrm>
+            <a:off x="6336792" y="1645920"/>
+            <a:ext cx="4937760" cy="2103120"/>
+          </a:xfrm>
+          <a:prstGeom prst="roundRect">
+            <a:avLst/>
+          </a:prstGeom>
+          <a:solidFill>
+            <a:srgbClr val="121212"/>
+          </a:solidFill>
+          <a:ln w="12700">
+            <a:solidFill>
+              <a:srgbClr val="222222"/>
+            </a:solidFill>
+            <a:prstDash val="solid"/>
+          </a:ln>
+        </p:spPr>
+      </p:sp>
+      <p:sp>
+        <p:nvSpPr>
+          <p:cNvPr id="8" name="Text 6"/>
+          <p:cNvSpPr/>
+          <p:nvPr/>
+        </p:nvSpPr>
+        <p:spPr>
+          <a:xfrm>
+            <a:off x="6565392" y="1828800"/>
+            <a:ext cx="4480560" cy="365760"/>
+          </a:xfrm>
+          <a:prstGeom prst="rect">
+            <a:avLst/>
+          </a:prstGeom>
+          <a:noFill/>
+          <a:ln/>
+        </p:spPr>
+        <p:txBody>
+          <a:bodyPr wrap="square" rtlCol="0" anchor="ctr"/>
+          <a:lstStyle/>
+          <a:p>
+            <a:pPr indent="0" marL="0">
+              <a:buNone/>
+            </a:pPr>
+            <a:r>
+              <a:rPr lang="en-US" sz="1600" b="1" dirty="0">
+                <a:solidFill>
+                  <a:srgbClr val="00F3FF"/>
+                </a:solidFill>
+                <a:latin typeface="Outfit" pitchFamily="34" charset="0"/>
+                <a:ea typeface="Outfit" pitchFamily="34" charset="-122"/>
+                <a:cs typeface="Outfit" pitchFamily="34" charset="-120"/>
+              </a:rPr>
+              <a:t>02 / Terminal-Style Sandbox</a:t>
+            </a:r>
+            <a:endParaRPr lang="en-US" sz="1600" dirty="0"/>
+          </a:p>
+        </p:txBody>
+      </p:sp>
+      <p:sp>
+        <p:nvSpPr>
+          <p:cNvPr id="9" name="Text 7"/>
+          <p:cNvSpPr/>
+          <p:nvPr/>
+        </p:nvSpPr>
+        <p:spPr>
+          <a:xfrm>
+            <a:off x="6565392" y="2286000"/>
+            <a:ext cx="4480560" cy="1280160"/>
+          </a:xfrm>
+          <a:prstGeom prst="rect">
+            <a:avLst/>
+          </a:prstGeom>
+          <a:noFill/>
+          <a:ln/>
+        </p:spPr>
+        <p:txBody>
+          <a:bodyPr wrap="square" rtlCol="0" anchor="t"/>
+          <a:lstStyle/>
+          <a:p>
+            <a:pPr indent="0" marL="0">
+              <a:buNone/>
+            </a:pPr>
+            <a:r>
+              <a:rPr lang="en-US" sz="1300" dirty="0">
+                <a:solidFill>
+                  <a:srgbClr val="A0A0A0"/>
                 </a:solidFill>
                 <a:latin typeface="Inter" pitchFamily="34" charset="0"/>
                 <a:ea typeface="Inter" pitchFamily="34" charset="-122"/>
                 <a:cs typeface="Inter" pitchFamily="34" charset="-120"/>
               </a:rPr>
-              <a:t>A single, highly organized interface for exploring utility, AI, and development APIs.
-</a:t>
-            </a:r>
+              <a:t>Inspect active API payloads in real-time. Features copy-to-clipboard blocks and instantly formatted JSON schemas.</a:t>
+            </a:r>
+            <a:endParaRPr lang="en-US" sz="1300" dirty="0"/>
+          </a:p>
+        </p:txBody>
+      </p:sp>
+      <p:sp>
+        <p:nvSpPr>
+          <p:cNvPr id="10" name="Shape 8"/>
+          <p:cNvSpPr/>
+          <p:nvPr/>
+        </p:nvSpPr>
+        <p:spPr>
+          <a:xfrm>
+            <a:off x="914400" y="4114800"/>
+            <a:ext cx="4937760" cy="2103120"/>
+          </a:xfrm>
+          <a:prstGeom prst="roundRect">
+            <a:avLst/>
+          </a:prstGeom>
+          <a:solidFill>
+            <a:srgbClr val="121212"/>
+          </a:solidFill>
+          <a:ln w="12700">
+            <a:solidFill>
+              <a:srgbClr val="222222"/>
+            </a:solidFill>
+            <a:prstDash val="solid"/>
+          </a:ln>
+        </p:spPr>
+      </p:sp>
+      <p:sp>
+        <p:nvSpPr>
+          <p:cNvPr id="11" name="Text 9"/>
+          <p:cNvSpPr/>
+          <p:nvPr/>
+        </p:nvSpPr>
+        <p:spPr>
+          <a:xfrm>
+            <a:off x="1143000" y="4297680"/>
+            <a:ext cx="4480560" cy="365760"/>
+          </a:xfrm>
+          <a:prstGeom prst="rect">
+            <a:avLst/>
+          </a:prstGeom>
+          <a:noFill/>
+          <a:ln/>
+        </p:spPr>
+        <p:txBody>
+          <a:bodyPr wrap="square" rtlCol="0" anchor="ctr"/>
+          <a:lstStyle/>
+          <a:p>
             <a:pPr indent="0" marL="0">
               <a:buNone/>
             </a:pPr>
             <a:r>
               <a:rPr lang="en-US" sz="1600" b="1" dirty="0">
                 <a:solidFill>
-                  <a:srgbClr val="FFFFFF"/>
+                  <a:srgbClr val="00F3FF"/>
+                </a:solidFill>
+                <a:latin typeface="Outfit" pitchFamily="34" charset="0"/>
+                <a:ea typeface="Outfit" pitchFamily="34" charset="-122"/>
+                <a:cs typeface="Outfit" pitchFamily="34" charset="-120"/>
+              </a:rPr>
+              <a:t>03 / Integrated API Gateway</a:t>
+            </a:r>
+            <a:endParaRPr lang="en-US" sz="1600" dirty="0"/>
+          </a:p>
+        </p:txBody>
+      </p:sp>
+      <p:sp>
+        <p:nvSpPr>
+          <p:cNvPr id="12" name="Text 10"/>
+          <p:cNvSpPr/>
+          <p:nvPr/>
+        </p:nvSpPr>
+        <p:spPr>
+          <a:xfrm>
+            <a:off x="1143000" y="4754880"/>
+            <a:ext cx="4480560" cy="1280160"/>
+          </a:xfrm>
+          <a:prstGeom prst="rect">
+            <a:avLst/>
+          </a:prstGeom>
+          <a:noFill/>
+          <a:ln/>
+        </p:spPr>
+        <p:txBody>
+          <a:bodyPr wrap="square" rtlCol="0" anchor="t"/>
+          <a:lstStyle/>
+          <a:p>
+            <a:pPr indent="0" marL="0">
+              <a:buNone/>
+            </a:pPr>
+            <a:r>
+              <a:rPr lang="en-US" sz="1300" dirty="0">
+                <a:solidFill>
+                  <a:srgbClr val="A0A0A0"/>
                 </a:solidFill>
                 <a:latin typeface="Inter" pitchFamily="34" charset="0"/>
                 <a:ea typeface="Inter" pitchFamily="34" charset="-122"/>
                 <a:cs typeface="Inter" pitchFamily="34" charset="-120"/>
               </a:rPr>
-              <a:t>▪  Zero-Config Playground: </a:t>
-            </a:r>
-            <a:pPr indent="0" marL="0">
-              <a:buNone/>
-            </a:pPr>
-            <a:r>
-              <a:rPr lang="en-US" sz="1600" dirty="0">
-                <a:solidFill>
-                  <a:srgbClr val="AAAAAA"/>
+              <a:t>Under-the-hood controller handling unified request headers, route mapping, and network optimization.</a:t>
+            </a:r>
+            <a:endParaRPr lang="en-US" sz="1300" dirty="0"/>
+          </a:p>
+        </p:txBody>
+      </p:sp>
+      <p:sp>
+        <p:nvSpPr>
+          <p:cNvPr id="13" name="Shape 11"/>
+          <p:cNvSpPr/>
+          <p:nvPr/>
+        </p:nvSpPr>
+        <p:spPr>
+          <a:xfrm>
+            <a:off x="6336792" y="4114800"/>
+            <a:ext cx="4937760" cy="2103120"/>
+          </a:xfrm>
+          <a:prstGeom prst="roundRect">
+            <a:avLst/>
+          </a:prstGeom>
+          <a:solidFill>
+            <a:srgbClr val="121212"/>
+          </a:solidFill>
+          <a:ln w="12700">
+            <a:solidFill>
+              <a:srgbClr val="222222"/>
+            </a:solidFill>
+            <a:prstDash val="solid"/>
+          </a:ln>
+        </p:spPr>
+      </p:sp>
+      <p:sp>
+        <p:nvSpPr>
+          <p:cNvPr id="14" name="Text 12"/>
+          <p:cNvSpPr/>
+          <p:nvPr/>
+        </p:nvSpPr>
+        <p:spPr>
+          <a:xfrm>
+            <a:off x="6565392" y="4297680"/>
+            <a:ext cx="4480560" cy="365760"/>
+          </a:xfrm>
+          <a:prstGeom prst="rect">
+            <a:avLst/>
+          </a:prstGeom>
+          <a:noFill/>
+          <a:ln/>
+        </p:spPr>
+        <p:txBody>
+          <a:bodyPr wrap="square" rtlCol="0" anchor="ctr"/>
+          <a:lstStyle/>
+          <a:p>
+            <a:pPr indent="0" marL="0">
+              <a:buNone/>
+            </a:pPr>
+            <a:r>
+              <a:rPr lang="en-US" sz="1600" b="1" dirty="0">
+                <a:solidFill>
+                  <a:srgbClr val="00F3FF"/>
+                </a:solidFill>
+                <a:latin typeface="Outfit" pitchFamily="34" charset="0"/>
+                <a:ea typeface="Outfit" pitchFamily="34" charset="-122"/>
+                <a:cs typeface="Outfit" pitchFamily="34" charset="-120"/>
+              </a:rPr>
+              <a:t>04 / Consumer Analytics Dashboard</a:t>
+            </a:r>
+            <a:endParaRPr lang="en-US" sz="1600" dirty="0"/>
+          </a:p>
+        </p:txBody>
+      </p:sp>
+      <p:sp>
+        <p:nvSpPr>
+          <p:cNvPr id="15" name="Text 13"/>
+          <p:cNvSpPr/>
+          <p:nvPr/>
+        </p:nvSpPr>
+        <p:spPr>
+          <a:xfrm>
+            <a:off x="6565392" y="4754880"/>
+            <a:ext cx="4480560" cy="1280160"/>
+          </a:xfrm>
+          <a:prstGeom prst="rect">
+            <a:avLst/>
+          </a:prstGeom>
+          <a:noFill/>
+          <a:ln/>
+        </p:spPr>
+        <p:txBody>
+          <a:bodyPr wrap="square" rtlCol="0" anchor="t"/>
+          <a:lstStyle/>
+          <a:p>
+            <a:pPr indent="0" marL="0">
+              <a:buNone/>
+            </a:pPr>
+            <a:r>
+              <a:rPr lang="en-US" sz="1300" dirty="0">
+                <a:solidFill>
+                  <a:srgbClr val="A0A0A0"/>
                 </a:solidFill>
                 <a:latin typeface="Inter" pitchFamily="34" charset="0"/>
                 <a:ea typeface="Inter" pitchFamily="34" charset="-122"/>
                 <a:cs typeface="Inter" pitchFamily="34" charset="-120"/>
               </a:rPr>
-              <a:t>Test and inspect JSON payloads live in the browser using an interactive, terminal-style playground environment.
-</a:t>
-            </a:r>
-            <a:pPr indent="0" marL="0">
-              <a:buNone/>
-            </a:pPr>
-            <a:r>
-              <a:rPr lang="en-US" sz="1600" b="1" dirty="0">
-                <a:solidFill>
-                  <a:srgbClr val="FFFFFF"/>
-                </a:solidFill>
-                <a:latin typeface="Inter" pitchFamily="34" charset="0"/>
-                <a:ea typeface="Inter" pitchFamily="34" charset="-122"/>
-                <a:cs typeface="Inter" pitchFamily="34" charset="-120"/>
-              </a:rPr>
-              <a:t>▪  Robust API Gateway Model: </a:t>
-            </a:r>
-            <a:pPr indent="0" marL="0">
-              <a:buNone/>
-            </a:pPr>
-            <a:r>
-              <a:rPr lang="en-US" sz="1600" dirty="0">
-                <a:solidFill>
-                  <a:srgbClr val="AAAAAA"/>
-                </a:solidFill>
-                <a:latin typeface="Inter" pitchFamily="34" charset="0"/>
-                <a:ea typeface="Inter" pitchFamily="34" charset="-122"/>
-                <a:cs typeface="Inter" pitchFamily="34" charset="-120"/>
-              </a:rPr>
-              <a:t>Behind-the-scenes microservices setup that handles secure request routing, network optimization, and uniform headers.
-</a:t>
-            </a:r>
-            <a:pPr indent="0" marL="0">
-              <a:buNone/>
-            </a:pPr>
-            <a:r>
-              <a:rPr lang="en-US" sz="1600" b="1" dirty="0">
-                <a:solidFill>
-                  <a:srgbClr val="FFFFFF"/>
-                </a:solidFill>
-                <a:latin typeface="Inter" pitchFamily="34" charset="0"/>
-                <a:ea typeface="Inter" pitchFamily="34" charset="-122"/>
-                <a:cs typeface="Inter" pitchFamily="34" charset="-120"/>
-              </a:rPr>
-              <a:t>▪  Live Developer Dashboard: </a:t>
-            </a:r>
-            <a:pPr indent="0" marL="0">
-              <a:buNone/>
-            </a:pPr>
-            <a:r>
-              <a:rPr lang="en-US" sz="1600" dirty="0">
-                <a:solidFill>
-                  <a:srgbClr val="AAAAAA"/>
-                </a:solidFill>
-                <a:latin typeface="Inter" pitchFamily="34" charset="0"/>
-                <a:ea typeface="Inter" pitchFamily="34" charset="-122"/>
-                <a:cs typeface="Inter" pitchFamily="34" charset="-120"/>
-              </a:rPr>
-              <a:t>Gives consumers instant access to their client keys, usage metrics, data traffic records, and latency logs.</a:t>
-            </a:r>
-            <a:endParaRPr lang="en-US" sz="1600" dirty="0"/>
+              <a:t>A private workspace showing generated keys, data usage limits, latencies, and transaction logs.</a:t>
+            </a:r>
+            <a:endParaRPr lang="en-US" sz="1300" dirty="0"/>
           </a:p>
         </p:txBody>
       </p:sp>
@@ -1840,7 +2444,7 @@
     <p:bg>
       <p:bgPr>
         <a:solidFill>
-          <a:srgbClr val="0D0D0D"/>
+          <a:srgbClr val="080808"/>
         </a:solidFill>
       </p:bgPr>
     </p:bg>
@@ -1866,7 +2470,7 @@
         </p:nvSpPr>
         <p:spPr>
           <a:xfrm>
-            <a:off x="914400" y="548640"/>
+            <a:off x="914400" y="457200"/>
             <a:ext cx="10360152" cy="731520"/>
           </a:xfrm>
           <a:prstGeom prst="rect">
@@ -1883,7 +2487,7 @@
               <a:buNone/>
             </a:pPr>
             <a:r>
-              <a:rPr lang="en-US" sz="3600" b="1" dirty="0">
+              <a:rPr lang="en-US" sz="3200" b="1" dirty="0">
                 <a:solidFill>
                   <a:srgbClr val="00F3FF"/>
                 </a:solidFill>
@@ -1893,20 +2497,65 @@
               </a:rPr>
               <a:t>Why API Corner?</a:t>
             </a:r>
-            <a:endParaRPr lang="en-US" sz="3600" dirty="0"/>
-          </a:p>
-        </p:txBody>
-      </p:sp>
-      <p:sp>
-        <p:nvSpPr>
-          <p:cNvPr id="3" name="Text 1"/>
+            <a:endParaRPr lang="en-US" sz="3200" dirty="0"/>
+          </a:p>
+        </p:txBody>
+      </p:sp>
+      <p:sp>
+        <p:nvSpPr>
+          <p:cNvPr id="3" name="Shape 1"/>
+          <p:cNvSpPr/>
+          <p:nvPr/>
+        </p:nvSpPr>
+        <p:spPr>
+          <a:xfrm>
+            <a:off x="914400" y="1143000"/>
+            <a:ext cx="1828800" cy="36576"/>
+          </a:xfrm>
+          <a:prstGeom prst="rect">
+            <a:avLst/>
+          </a:prstGeom>
+          <a:solidFill>
+            <a:srgbClr val="00F3FF"/>
+          </a:solidFill>
+          <a:ln/>
+        </p:spPr>
+      </p:sp>
+      <p:sp>
+        <p:nvSpPr>
+          <p:cNvPr id="4" name="Shape 2"/>
           <p:cNvSpPr/>
           <p:nvPr/>
         </p:nvSpPr>
         <p:spPr>
           <a:xfrm>
             <a:off x="914400" y="1645920"/>
-            <a:ext cx="10360152" cy="4572000"/>
+            <a:ext cx="4937760" cy="2103120"/>
+          </a:xfrm>
+          <a:prstGeom prst="roundRect">
+            <a:avLst/>
+          </a:prstGeom>
+          <a:solidFill>
+            <a:srgbClr val="121212"/>
+          </a:solidFill>
+          <a:ln w="12700">
+            <a:solidFill>
+              <a:srgbClr val="222222"/>
+            </a:solidFill>
+            <a:prstDash val="solid"/>
+          </a:ln>
+        </p:spPr>
+      </p:sp>
+      <p:sp>
+        <p:nvSpPr>
+          <p:cNvPr id="5" name="Text 3"/>
+          <p:cNvSpPr/>
+          <p:nvPr/>
+        </p:nvSpPr>
+        <p:spPr>
+          <a:xfrm>
+            <a:off x="1143000" y="1828800"/>
+            <a:ext cx="4480560" cy="365760"/>
           </a:xfrm>
           <a:prstGeom prst="rect">
             <a:avLst/>
@@ -1924,116 +2573,363 @@
             <a:r>
               <a:rPr lang="en-US" sz="1600" b="1" dirty="0">
                 <a:solidFill>
-                  <a:srgbClr val="FFFFFF"/>
+                  <a:srgbClr val="00F3FF"/>
+                </a:solidFill>
+                <a:latin typeface="Outfit" pitchFamily="34" charset="0"/>
+                <a:ea typeface="Outfit" pitchFamily="34" charset="-122"/>
+                <a:cs typeface="Outfit" pitchFamily="34" charset="-120"/>
+              </a:rPr>
+              <a:t>Modern Aesthetics</a:t>
+            </a:r>
+            <a:endParaRPr lang="en-US" sz="1600" dirty="0"/>
+          </a:p>
+        </p:txBody>
+      </p:sp>
+      <p:sp>
+        <p:nvSpPr>
+          <p:cNvPr id="6" name="Text 4"/>
+          <p:cNvSpPr/>
+          <p:nvPr/>
+        </p:nvSpPr>
+        <p:spPr>
+          <a:xfrm>
+            <a:off x="1143000" y="2286000"/>
+            <a:ext cx="4480560" cy="1280160"/>
+          </a:xfrm>
+          <a:prstGeom prst="rect">
+            <a:avLst/>
+          </a:prstGeom>
+          <a:noFill/>
+          <a:ln/>
+        </p:spPr>
+        <p:txBody>
+          <a:bodyPr wrap="square" rtlCol="0" anchor="t"/>
+          <a:lstStyle/>
+          <a:p>
+            <a:pPr indent="0" marL="0">
+              <a:buNone/>
+            </a:pPr>
+            <a:r>
+              <a:rPr lang="en-US" sz="1300" dirty="0">
+                <a:solidFill>
+                  <a:srgbClr val="A0A0A0"/>
                 </a:solidFill>
                 <a:latin typeface="Inter" pitchFamily="34" charset="0"/>
                 <a:ea typeface="Inter" pitchFamily="34" charset="-122"/>
                 <a:cs typeface="Inter" pitchFamily="34" charset="-120"/>
               </a:rPr>
-              <a:t>▪  Cutting-Edge Visual Aesthetics: </a:t>
-            </a:r>
-            <a:pPr indent="0" marL="0">
-              <a:buNone/>
-            </a:pPr>
-            <a:r>
-              <a:rPr lang="en-US" sz="1600" dirty="0">
-                <a:solidFill>
-                  <a:srgbClr val="AAAAAA"/>
+              <a:t>Engineered using clean glassmorphism patterns, micro-animations, and a highly polished grayscale &amp; neon blue styling.</a:t>
+            </a:r>
+            <a:endParaRPr lang="en-US" sz="1300" dirty="0"/>
+          </a:p>
+        </p:txBody>
+      </p:sp>
+      <p:sp>
+        <p:nvSpPr>
+          <p:cNvPr id="7" name="Shape 5"/>
+          <p:cNvSpPr/>
+          <p:nvPr/>
+        </p:nvSpPr>
+        <p:spPr>
+          <a:xfrm>
+            <a:off x="6336792" y="1645920"/>
+            <a:ext cx="4937760" cy="2103120"/>
+          </a:xfrm>
+          <a:prstGeom prst="roundRect">
+            <a:avLst/>
+          </a:prstGeom>
+          <a:solidFill>
+            <a:srgbClr val="121212"/>
+          </a:solidFill>
+          <a:ln w="12700">
+            <a:solidFill>
+              <a:srgbClr val="222222"/>
+            </a:solidFill>
+            <a:prstDash val="solid"/>
+          </a:ln>
+        </p:spPr>
+      </p:sp>
+      <p:sp>
+        <p:nvSpPr>
+          <p:cNvPr id="8" name="Text 6"/>
+          <p:cNvSpPr/>
+          <p:nvPr/>
+        </p:nvSpPr>
+        <p:spPr>
+          <a:xfrm>
+            <a:off x="6565392" y="1828800"/>
+            <a:ext cx="4480560" cy="365760"/>
+          </a:xfrm>
+          <a:prstGeom prst="rect">
+            <a:avLst/>
+          </a:prstGeom>
+          <a:noFill/>
+          <a:ln/>
+        </p:spPr>
+        <p:txBody>
+          <a:bodyPr wrap="square" rtlCol="0" anchor="ctr"/>
+          <a:lstStyle/>
+          <a:p>
+            <a:pPr indent="0" marL="0">
+              <a:buNone/>
+            </a:pPr>
+            <a:r>
+              <a:rPr lang="en-US" sz="1600" b="1" dirty="0">
+                <a:solidFill>
+                  <a:srgbClr val="00F3FF"/>
+                </a:solidFill>
+                <a:latin typeface="Outfit" pitchFamily="34" charset="0"/>
+                <a:ea typeface="Outfit" pitchFamily="34" charset="-122"/>
+                <a:cs typeface="Outfit" pitchFamily="34" charset="-120"/>
+              </a:rPr>
+              <a:t>Portfolio Integration</a:t>
+            </a:r>
+            <a:endParaRPr lang="en-US" sz="1600" dirty="0"/>
+          </a:p>
+        </p:txBody>
+      </p:sp>
+      <p:sp>
+        <p:nvSpPr>
+          <p:cNvPr id="9" name="Text 7"/>
+          <p:cNvSpPr/>
+          <p:nvPr/>
+        </p:nvSpPr>
+        <p:spPr>
+          <a:xfrm>
+            <a:off x="6565392" y="2286000"/>
+            <a:ext cx="4480560" cy="1280160"/>
+          </a:xfrm>
+          <a:prstGeom prst="rect">
+            <a:avLst/>
+          </a:prstGeom>
+          <a:noFill/>
+          <a:ln/>
+        </p:spPr>
+        <p:txBody>
+          <a:bodyPr wrap="square" rtlCol="0" anchor="t"/>
+          <a:lstStyle/>
+          <a:p>
+            <a:pPr indent="0" marL="0">
+              <a:buNone/>
+            </a:pPr>
+            <a:r>
+              <a:rPr lang="en-US" sz="1300" dirty="0">
+                <a:solidFill>
+                  <a:srgbClr val="A0A0A0"/>
                 </a:solidFill>
                 <a:latin typeface="Inter" pitchFamily="34" charset="0"/>
                 <a:ea typeface="Inter" pitchFamily="34" charset="-122"/>
                 <a:cs typeface="Inter" pitchFamily="34" charset="-120"/>
               </a:rPr>
-              <a:t>Built with a state-of-the-art glassmorphism design system, smooth fade-in animations, and a monochrome/neon-cyan color scheme.
-</a:t>
-            </a:r>
+              <a:t>Directly aggregates Karthikeya's 'AI ROI Performance Analyzer' to run predictive insight queries in real time.</a:t>
+            </a:r>
+            <a:endParaRPr lang="en-US" sz="1300" dirty="0"/>
+          </a:p>
+        </p:txBody>
+      </p:sp>
+      <p:sp>
+        <p:nvSpPr>
+          <p:cNvPr id="10" name="Shape 8"/>
+          <p:cNvSpPr/>
+          <p:nvPr/>
+        </p:nvSpPr>
+        <p:spPr>
+          <a:xfrm>
+            <a:off x="914400" y="4114800"/>
+            <a:ext cx="4937760" cy="2103120"/>
+          </a:xfrm>
+          <a:prstGeom prst="roundRect">
+            <a:avLst/>
+          </a:prstGeom>
+          <a:solidFill>
+            <a:srgbClr val="121212"/>
+          </a:solidFill>
+          <a:ln w="12700">
+            <a:solidFill>
+              <a:srgbClr val="222222"/>
+            </a:solidFill>
+            <a:prstDash val="solid"/>
+          </a:ln>
+        </p:spPr>
+      </p:sp>
+      <p:sp>
+        <p:nvSpPr>
+          <p:cNvPr id="11" name="Text 9"/>
+          <p:cNvSpPr/>
+          <p:nvPr/>
+        </p:nvSpPr>
+        <p:spPr>
+          <a:xfrm>
+            <a:off x="1143000" y="4297680"/>
+            <a:ext cx="4480560" cy="365760"/>
+          </a:xfrm>
+          <a:prstGeom prst="rect">
+            <a:avLst/>
+          </a:prstGeom>
+          <a:noFill/>
+          <a:ln/>
+        </p:spPr>
+        <p:txBody>
+          <a:bodyPr wrap="square" rtlCol="0" anchor="ctr"/>
+          <a:lstStyle/>
+          <a:p>
             <a:pPr indent="0" marL="0">
               <a:buNone/>
             </a:pPr>
             <a:r>
               <a:rPr lang="en-US" sz="1600" b="1" dirty="0">
                 <a:solidFill>
-                  <a:srgbClr val="FFFFFF"/>
+                  <a:srgbClr val="00F3FF"/>
+                </a:solidFill>
+                <a:latin typeface="Outfit" pitchFamily="34" charset="0"/>
+                <a:ea typeface="Outfit" pitchFamily="34" charset="-122"/>
+                <a:cs typeface="Outfit" pitchFamily="34" charset="-120"/>
+              </a:rPr>
+              <a:t>Production Guardrails</a:t>
+            </a:r>
+            <a:endParaRPr lang="en-US" sz="1600" dirty="0"/>
+          </a:p>
+        </p:txBody>
+      </p:sp>
+      <p:sp>
+        <p:nvSpPr>
+          <p:cNvPr id="12" name="Text 10"/>
+          <p:cNvSpPr/>
+          <p:nvPr/>
+        </p:nvSpPr>
+        <p:spPr>
+          <a:xfrm>
+            <a:off x="1143000" y="4754880"/>
+            <a:ext cx="4480560" cy="1280160"/>
+          </a:xfrm>
+          <a:prstGeom prst="rect">
+            <a:avLst/>
+          </a:prstGeom>
+          <a:noFill/>
+          <a:ln/>
+        </p:spPr>
+        <p:txBody>
+          <a:bodyPr wrap="square" rtlCol="0" anchor="t"/>
+          <a:lstStyle/>
+          <a:p>
+            <a:pPr indent="0" marL="0">
+              <a:buNone/>
+            </a:pPr>
+            <a:r>
+              <a:rPr lang="en-US" sz="1300" dirty="0">
+                <a:solidFill>
+                  <a:srgbClr val="A0A0A0"/>
                 </a:solidFill>
                 <a:latin typeface="Inter" pitchFamily="34" charset="0"/>
                 <a:ea typeface="Inter" pitchFamily="34" charset="-122"/>
                 <a:cs typeface="Inter" pitchFamily="34" charset="-120"/>
               </a:rPr>
-              <a:t>▪  Direct Resume Link: AI ROI Performance Analyzer: </a:t>
-            </a:r>
-            <a:pPr indent="0" marL="0">
-              <a:buNone/>
-            </a:pPr>
-            <a:r>
-              <a:rPr lang="en-US" sz="1600" dirty="0">
-                <a:solidFill>
-                  <a:srgbClr val="AAAAAA"/>
+              <a:t>Includes secure client token generation, cryptographic authorization headers, and simulated delay limits to defend services.</a:t>
+            </a:r>
+            <a:endParaRPr lang="en-US" sz="1300" dirty="0"/>
+          </a:p>
+        </p:txBody>
+      </p:sp>
+      <p:sp>
+        <p:nvSpPr>
+          <p:cNvPr id="13" name="Shape 11"/>
+          <p:cNvSpPr/>
+          <p:nvPr/>
+        </p:nvSpPr>
+        <p:spPr>
+          <a:xfrm>
+            <a:off x="6336792" y="4114800"/>
+            <a:ext cx="4937760" cy="2103120"/>
+          </a:xfrm>
+          <a:prstGeom prst="roundRect">
+            <a:avLst/>
+          </a:prstGeom>
+          <a:solidFill>
+            <a:srgbClr val="121212"/>
+          </a:solidFill>
+          <a:ln w="12700">
+            <a:solidFill>
+              <a:srgbClr val="222222"/>
+            </a:solidFill>
+            <a:prstDash val="solid"/>
+          </a:ln>
+        </p:spPr>
+      </p:sp>
+      <p:sp>
+        <p:nvSpPr>
+          <p:cNvPr id="14" name="Text 12"/>
+          <p:cNvSpPr/>
+          <p:nvPr/>
+        </p:nvSpPr>
+        <p:spPr>
+          <a:xfrm>
+            <a:off x="6565392" y="4297680"/>
+            <a:ext cx="4480560" cy="365760"/>
+          </a:xfrm>
+          <a:prstGeom prst="rect">
+            <a:avLst/>
+          </a:prstGeom>
+          <a:noFill/>
+          <a:ln/>
+        </p:spPr>
+        <p:txBody>
+          <a:bodyPr wrap="square" rtlCol="0" anchor="ctr"/>
+          <a:lstStyle/>
+          <a:p>
+            <a:pPr indent="0" marL="0">
+              <a:buNone/>
+            </a:pPr>
+            <a:r>
+              <a:rPr lang="en-US" sz="1600" b="1" dirty="0">
+                <a:solidFill>
+                  <a:srgbClr val="00F3FF"/>
+                </a:solidFill>
+                <a:latin typeface="Outfit" pitchFamily="34" charset="0"/>
+                <a:ea typeface="Outfit" pitchFamily="34" charset="-122"/>
+                <a:cs typeface="Outfit" pitchFamily="34" charset="-120"/>
+              </a:rPr>
+              <a:t>Developer Velocity</a:t>
+            </a:r>
+            <a:endParaRPr lang="en-US" sz="1600" dirty="0"/>
+          </a:p>
+        </p:txBody>
+      </p:sp>
+      <p:sp>
+        <p:nvSpPr>
+          <p:cNvPr id="15" name="Text 13"/>
+          <p:cNvSpPr/>
+          <p:nvPr/>
+        </p:nvSpPr>
+        <p:spPr>
+          <a:xfrm>
+            <a:off x="6565392" y="4754880"/>
+            <a:ext cx="4480560" cy="1280160"/>
+          </a:xfrm>
+          <a:prstGeom prst="rect">
+            <a:avLst/>
+          </a:prstGeom>
+          <a:noFill/>
+          <a:ln/>
+        </p:spPr>
+        <p:txBody>
+          <a:bodyPr wrap="square" rtlCol="0" anchor="t"/>
+          <a:lstStyle/>
+          <a:p>
+            <a:pPr indent="0" marL="0">
+              <a:buNone/>
+            </a:pPr>
+            <a:r>
+              <a:rPr lang="en-US" sz="1300" dirty="0">
+                <a:solidFill>
+                  <a:srgbClr val="A0A0A0"/>
                 </a:solidFill>
                 <a:latin typeface="Inter" pitchFamily="34" charset="0"/>
                 <a:ea typeface="Inter" pitchFamily="34" charset="-122"/>
                 <a:cs typeface="Inter" pitchFamily="34" charset="-120"/>
               </a:rPr>
-              <a:t>Seamless integration with Karthikeya's core AI analytics project, exposing machine learning prediction endpoints directly to consumers.
-</a:t>
-            </a:r>
-            <a:pPr indent="0" marL="0">
-              <a:buNone/>
-            </a:pPr>
-            <a:r>
-              <a:rPr lang="en-US" sz="1600" b="1" dirty="0">
-                <a:solidFill>
-                  <a:srgbClr val="FFFFFF"/>
-                </a:solidFill>
-                <a:latin typeface="Inter" pitchFamily="34" charset="0"/>
-                <a:ea typeface="Inter" pitchFamily="34" charset="-122"/>
-                <a:cs typeface="Inter" pitchFamily="34" charset="-120"/>
-              </a:rPr>
-              <a:t>▪  Built for Production Scale: </a:t>
-            </a:r>
-            <a:pPr indent="0" marL="0">
-              <a:buNone/>
-            </a:pPr>
-            <a:r>
-              <a:rPr lang="en-US" sz="1600" dirty="0">
-                <a:solidFill>
-                  <a:srgbClr val="AAAAAA"/>
-                </a:solidFill>
-                <a:latin typeface="Inter" pitchFamily="34" charset="0"/>
-                <a:ea typeface="Inter" pitchFamily="34" charset="-122"/>
-                <a:cs typeface="Inter" pitchFamily="34" charset="-120"/>
-              </a:rPr>
-              <a:t>Leverages standard API protection techniques (Rate-Limiting, API key authentication) to prevent DDoS attacks and server overloads.
-</a:t>
-            </a:r>
-            <a:pPr indent="0" marL="0">
-              <a:buNone/>
-            </a:pPr>
-            <a:r>
-              <a:rPr lang="en-US" sz="1600" b="1" dirty="0">
-                <a:solidFill>
-                  <a:srgbClr val="FFFFFF"/>
-                </a:solidFill>
-                <a:latin typeface="Inter" pitchFamily="34" charset="0"/>
-                <a:ea typeface="Inter" pitchFamily="34" charset="-122"/>
-                <a:cs typeface="Inter" pitchFamily="34" charset="-120"/>
-              </a:rPr>
-              <a:t>▪  Streamlined Onboarding: </a:t>
-            </a:r>
-            <a:pPr indent="0" marL="0">
-              <a:buNone/>
-            </a:pPr>
-            <a:r>
-              <a:rPr lang="en-US" sz="1600" dirty="0">
-                <a:solidFill>
-                  <a:srgbClr val="AAAAAA"/>
-                </a:solidFill>
-                <a:latin typeface="Inter" pitchFamily="34" charset="0"/>
-                <a:ea typeface="Inter" pitchFamily="34" charset="-122"/>
-                <a:cs typeface="Inter" pitchFamily="34" charset="-120"/>
-              </a:rPr>
-              <a:t>Offers fast social login workflows (GitHub &amp; Email) enabling developers to deploy applications in under 60 seconds.</a:t>
-            </a:r>
-            <a:endParaRPr lang="en-US" sz="1600" dirty="0"/>
+              <a:t>Instant registration with zero friction, offering social git profiles to start query testing under one minute.</a:t>
+            </a:r>
+            <a:endParaRPr lang="en-US" sz="1300" dirty="0"/>
           </a:p>
         </p:txBody>
       </p:sp>
@@ -2051,7 +2947,7 @@
     <p:bg>
       <p:bgPr>
         <a:solidFill>
-          <a:srgbClr val="0D0D0D"/>
+          <a:srgbClr val="080808"/>
         </a:solidFill>
       </p:bgPr>
     </p:bg>
@@ -2077,7 +2973,7 @@
         </p:nvSpPr>
         <p:spPr>
           <a:xfrm>
-            <a:off x="914400" y="548640"/>
+            <a:off x="914400" y="457200"/>
             <a:ext cx="10360152" cy="731520"/>
           </a:xfrm>
           <a:prstGeom prst="rect">
@@ -2094,7 +2990,7 @@
               <a:buNone/>
             </a:pPr>
             <a:r>
-              <a:rPr lang="en-US" sz="3600" b="1" dirty="0">
+              <a:rPr lang="en-US" sz="3200" b="1" dirty="0">
                 <a:solidFill>
                   <a:srgbClr val="00F3FF"/>
                 </a:solidFill>
@@ -2102,22 +2998,67 @@
                 <a:ea typeface="Outfit" pitchFamily="34" charset="-122"/>
                 <a:cs typeface="Outfit" pitchFamily="34" charset="-120"/>
               </a:rPr>
-              <a:t>Technical Architecture &amp; Tech Stack</a:t>
-            </a:r>
-            <a:endParaRPr lang="en-US" sz="3600" dirty="0"/>
-          </a:p>
-        </p:txBody>
-      </p:sp>
-      <p:sp>
-        <p:nvSpPr>
-          <p:cNvPr id="3" name="Text 1"/>
+              <a:t>Technical Architecture &amp; Stack</a:t>
+            </a:r>
+            <a:endParaRPr lang="en-US" sz="3200" dirty="0"/>
+          </a:p>
+        </p:txBody>
+      </p:sp>
+      <p:sp>
+        <p:nvSpPr>
+          <p:cNvPr id="3" name="Shape 1"/>
+          <p:cNvSpPr/>
+          <p:nvPr/>
+        </p:nvSpPr>
+        <p:spPr>
+          <a:xfrm>
+            <a:off x="914400" y="1143000"/>
+            <a:ext cx="1828800" cy="36576"/>
+          </a:xfrm>
+          <a:prstGeom prst="rect">
+            <a:avLst/>
+          </a:prstGeom>
+          <a:solidFill>
+            <a:srgbClr val="00F3FF"/>
+          </a:solidFill>
+          <a:ln/>
+        </p:spPr>
+      </p:sp>
+      <p:sp>
+        <p:nvSpPr>
+          <p:cNvPr id="4" name="Shape 2"/>
           <p:cNvSpPr/>
           <p:nvPr/>
         </p:nvSpPr>
         <p:spPr>
           <a:xfrm>
             <a:off x="914400" y="1645920"/>
-            <a:ext cx="4572000" cy="4572000"/>
+            <a:ext cx="4937760" cy="4572000"/>
+          </a:xfrm>
+          <a:prstGeom prst="roundRect">
+            <a:avLst/>
+          </a:prstGeom>
+          <a:solidFill>
+            <a:srgbClr val="121212"/>
+          </a:solidFill>
+          <a:ln w="12700">
+            <a:solidFill>
+              <a:srgbClr val="222222"/>
+            </a:solidFill>
+            <a:prstDash val="solid"/>
+          </a:ln>
+        </p:spPr>
+      </p:sp>
+      <p:sp>
+        <p:nvSpPr>
+          <p:cNvPr id="5" name="Text 3"/>
+          <p:cNvSpPr/>
+          <p:nvPr/>
+        </p:nvSpPr>
+        <p:spPr>
+          <a:xfrm>
+            <a:off x="1143000" y="1828800"/>
+            <a:ext cx="4480560" cy="365760"/>
           </a:xfrm>
           <a:prstGeom prst="rect">
             <a:avLst/>
@@ -2133,7 +3074,7 @@
               <a:buNone/>
             </a:pPr>
             <a:r>
-              <a:rPr lang="en-US" sz="2000" b="1" dirty="0">
+              <a:rPr lang="en-US" sz="1600" b="1" dirty="0">
                 <a:solidFill>
                   <a:srgbClr val="00F3FF"/>
                 </a:solidFill>
@@ -2141,280 +3082,307 @@
                 <a:ea typeface="Outfit" pitchFamily="34" charset="-122"/>
                 <a:cs typeface="Outfit" pitchFamily="34" charset="-120"/>
               </a:rPr>
-              <a:t>FRONTEND PRESENTATION LAYER
-</a:t>
-            </a:r>
-            <a:pPr indent="0" marL="0">
-              <a:buNone/>
-            </a:pPr>
-            <a:r>
-              <a:rPr lang="en-US" sz="1400" b="1" dirty="0">
-                <a:solidFill>
-                  <a:srgbClr val="FFFFFF"/>
+              <a:t>Frontend Presentation Layer</a:t>
+            </a:r>
+            <a:endParaRPr lang="en-US" sz="1600" dirty="0"/>
+          </a:p>
+        </p:txBody>
+      </p:sp>
+      <p:sp>
+        <p:nvSpPr>
+          <p:cNvPr id="6" name="Text 4"/>
+          <p:cNvSpPr/>
+          <p:nvPr/>
+        </p:nvSpPr>
+        <p:spPr>
+          <a:xfrm>
+            <a:off x="1143000" y="2286000"/>
+            <a:ext cx="4480560" cy="3749040"/>
+          </a:xfrm>
+          <a:prstGeom prst="rect">
+            <a:avLst/>
+          </a:prstGeom>
+          <a:noFill/>
+          <a:ln/>
+        </p:spPr>
+        <p:txBody>
+          <a:bodyPr wrap="square" rtlCol="0" anchor="t"/>
+          <a:lstStyle/>
+          <a:p>
+            <a:pPr indent="0" marL="0">
+              <a:buNone/>
+            </a:pPr>
+            <a:r>
+              <a:rPr lang="en-US" sz="1300" dirty="0">
+                <a:solidFill>
+                  <a:srgbClr val="A0A0A0"/>
                 </a:solidFill>
                 <a:latin typeface="Inter" pitchFamily="34" charset="0"/>
                 <a:ea typeface="Inter" pitchFamily="34" charset="-122"/>
                 <a:cs typeface="Inter" pitchFamily="34" charset="-120"/>
               </a:rPr>
-              <a:t>▪  React.js (Vite): </a:t>
-            </a:r>
-            <a:pPr indent="0" marL="0">
-              <a:buNone/>
-            </a:pPr>
-            <a:r>
-              <a:rPr lang="en-US" sz="1400" dirty="0">
-                <a:solidFill>
-                  <a:srgbClr val="AAAAAA"/>
+              <a:t>▪ React.js (Vite): Modular UI structure ensuring fast single-page app loading.</a:t>
+            </a:r>
+            <a:pPr indent="0" marL="0">
+              <a:buNone/>
+            </a:pPr>
+            <a:r>
+              <a:rPr lang="en-US" sz="1200" dirty="0">
+                <a:solidFill>
+                  <a:srgbClr val="000000"/>
+                </a:solidFill>
+              </a:rPr>
+              <a:t>
+</a:t>
+            </a:r>
+            <a:pPr indent="0" marL="0">
+              <a:buNone/>
+            </a:pPr>
+            <a:r>
+              <a:rPr lang="en-US" sz="1300" dirty="0">
+                <a:solidFill>
+                  <a:srgbClr val="A0A0A0"/>
                 </a:solidFill>
                 <a:latin typeface="Inter" pitchFamily="34" charset="0"/>
                 <a:ea typeface="Inter" pitchFamily="34" charset="-122"/>
                 <a:cs typeface="Inter" pitchFamily="34" charset="-120"/>
               </a:rPr>
-              <a:t>Fast rendering speed and component modularity.
+              <a:t>▪ Vanilla CSS System: Flexible styling representing glows, card borders, and dark mode layouts.</a:t>
+            </a:r>
+            <a:pPr indent="0" marL="0">
+              <a:buNone/>
+            </a:pPr>
+            <a:r>
+              <a:rPr lang="en-US" sz="1200" dirty="0">
+                <a:solidFill>
+                  <a:srgbClr val="000000"/>
+                </a:solidFill>
+              </a:rPr>
+              <a:t>
 </a:t>
             </a:r>
             <a:pPr indent="0" marL="0">
               <a:buNone/>
             </a:pPr>
             <a:r>
-              <a:rPr lang="en-US" sz="1400" b="1" dirty="0">
-                <a:solidFill>
-                  <a:srgbClr val="FFFFFF"/>
+              <a:rPr lang="en-US" sz="1300" dirty="0">
+                <a:solidFill>
+                  <a:srgbClr val="A0A0A0"/>
                 </a:solidFill>
                 <a:latin typeface="Inter" pitchFamily="34" charset="0"/>
                 <a:ea typeface="Inter" pitchFamily="34" charset="-122"/>
                 <a:cs typeface="Inter" pitchFamily="34" charset="-120"/>
               </a:rPr>
-              <a:t>▪  Vanilla CSS System: </a:t>
-            </a:r>
-            <a:pPr indent="0" marL="0">
-              <a:buNone/>
-            </a:pPr>
-            <a:r>
-              <a:rPr lang="en-US" sz="1400" dirty="0">
-                <a:solidFill>
-                  <a:srgbClr val="AAAAAA"/>
+              <a:t>▪ State Router: Seamless navigation across Dashboard, Auth dashboard, and API detailed logs.</a:t>
+            </a:r>
+            <a:pPr indent="0" marL="0">
+              <a:buNone/>
+            </a:pPr>
+            <a:r>
+              <a:rPr lang="en-US" sz="1200" dirty="0">
+                <a:solidFill>
+                  <a:srgbClr val="000000"/>
+                </a:solidFill>
+              </a:rPr>
+              <a:t>
+</a:t>
+            </a:r>
+            <a:pPr indent="0" marL="0">
+              <a:buNone/>
+            </a:pPr>
+            <a:r>
+              <a:rPr lang="en-US" sz="1300" dirty="0">
+                <a:solidFill>
+                  <a:srgbClr val="A0A0A0"/>
                 </a:solidFill>
                 <a:latin typeface="Inter" pitchFamily="34" charset="0"/>
                 <a:ea typeface="Inter" pitchFamily="34" charset="-122"/>
                 <a:cs typeface="Inter" pitchFamily="34" charset="-120"/>
               </a:rPr>
-              <a:t>Handles keyframe glows, dark mode variables, and backdrop filters.
-</a:t>
-            </a:r>
-            <a:pPr indent="0" marL="0">
-              <a:buNone/>
-            </a:pPr>
-            <a:r>
-              <a:rPr lang="en-US" sz="1400" b="1" dirty="0">
-                <a:solidFill>
-                  <a:srgbClr val="FFFFFF"/>
+              <a:t>▪ Lucide Icons: Glowing cyan vector representations.</a:t>
+            </a:r>
+            <a:endParaRPr lang="en-US" sz="1300" dirty="0"/>
+          </a:p>
+        </p:txBody>
+      </p:sp>
+      <p:sp>
+        <p:nvSpPr>
+          <p:cNvPr id="7" name="Shape 5"/>
+          <p:cNvSpPr/>
+          <p:nvPr/>
+        </p:nvSpPr>
+        <p:spPr>
+          <a:xfrm>
+            <a:off x="6336792" y="1645920"/>
+            <a:ext cx="4937760" cy="4572000"/>
+          </a:xfrm>
+          <a:prstGeom prst="roundRect">
+            <a:avLst/>
+          </a:prstGeom>
+          <a:solidFill>
+            <a:srgbClr val="121212"/>
+          </a:solidFill>
+          <a:ln w="12700">
+            <a:solidFill>
+              <a:srgbClr val="222222"/>
+            </a:solidFill>
+            <a:prstDash val="solid"/>
+          </a:ln>
+        </p:spPr>
+      </p:sp>
+      <p:sp>
+        <p:nvSpPr>
+          <p:cNvPr id="8" name="Text 6"/>
+          <p:cNvSpPr/>
+          <p:nvPr/>
+        </p:nvSpPr>
+        <p:spPr>
+          <a:xfrm>
+            <a:off x="6565392" y="1828800"/>
+            <a:ext cx="4480560" cy="365760"/>
+          </a:xfrm>
+          <a:prstGeom prst="rect">
+            <a:avLst/>
+          </a:prstGeom>
+          <a:noFill/>
+          <a:ln/>
+        </p:spPr>
+        <p:txBody>
+          <a:bodyPr wrap="square" rtlCol="0" anchor="ctr"/>
+          <a:lstStyle/>
+          <a:p>
+            <a:pPr indent="0" marL="0">
+              <a:buNone/>
+            </a:pPr>
+            <a:r>
+              <a:rPr lang="en-US" sz="1600" b="1" dirty="0">
+                <a:solidFill>
+                  <a:srgbClr val="00F3FF"/>
+                </a:solidFill>
+                <a:latin typeface="Outfit" pitchFamily="34" charset="0"/>
+                <a:ea typeface="Outfit" pitchFamily="34" charset="-122"/>
+                <a:cs typeface="Outfit" pitchFamily="34" charset="-120"/>
+              </a:rPr>
+              <a:t>Backend Microservices Layer</a:t>
+            </a:r>
+            <a:endParaRPr lang="en-US" sz="1600" dirty="0"/>
+          </a:p>
+        </p:txBody>
+      </p:sp>
+      <p:sp>
+        <p:nvSpPr>
+          <p:cNvPr id="9" name="Text 7"/>
+          <p:cNvSpPr/>
+          <p:nvPr/>
+        </p:nvSpPr>
+        <p:spPr>
+          <a:xfrm>
+            <a:off x="6565392" y="2286000"/>
+            <a:ext cx="4480560" cy="3749040"/>
+          </a:xfrm>
+          <a:prstGeom prst="rect">
+            <a:avLst/>
+          </a:prstGeom>
+          <a:noFill/>
+          <a:ln/>
+        </p:spPr>
+        <p:txBody>
+          <a:bodyPr wrap="square" rtlCol="0" anchor="t"/>
+          <a:lstStyle/>
+          <a:p>
+            <a:pPr indent="0" marL="0">
+              <a:buNone/>
+            </a:pPr>
+            <a:r>
+              <a:rPr lang="en-US" sz="1300" dirty="0">
+                <a:solidFill>
+                  <a:srgbClr val="A0A0A0"/>
                 </a:solidFill>
                 <a:latin typeface="Inter" pitchFamily="34" charset="0"/>
                 <a:ea typeface="Inter" pitchFamily="34" charset="-122"/>
                 <a:cs typeface="Inter" pitchFamily="34" charset="-120"/>
               </a:rPr>
-              <a:t>▪  React Router &amp; State: </a:t>
-            </a:r>
-            <a:pPr indent="0" marL="0">
-              <a:buNone/>
-            </a:pPr>
-            <a:r>
-              <a:rPr lang="en-US" sz="1400" dirty="0">
-                <a:solidFill>
-                  <a:srgbClr val="AAAAAA"/>
+              <a:t>▪ Python &amp; Node.js: High efficiency controllers and modular API servers.</a:t>
+            </a:r>
+            <a:pPr indent="0" marL="0">
+              <a:buNone/>
+            </a:pPr>
+            <a:r>
+              <a:rPr lang="en-US" sz="1200" dirty="0">
+                <a:solidFill>
+                  <a:srgbClr val="000000"/>
+                </a:solidFill>
+              </a:rPr>
+              <a:t>
+</a:t>
+            </a:r>
+            <a:pPr indent="0" marL="0">
+              <a:buNone/>
+            </a:pPr>
+            <a:r>
+              <a:rPr lang="en-US" sz="1300" dirty="0">
+                <a:solidFill>
+                  <a:srgbClr val="A0A0A0"/>
                 </a:solidFill>
                 <a:latin typeface="Inter" pitchFamily="34" charset="0"/>
                 <a:ea typeface="Inter" pitchFamily="34" charset="-122"/>
                 <a:cs typeface="Inter" pitchFamily="34" charset="-120"/>
               </a:rPr>
-              <a:t>Controls auth flags and routes between Dashboard, Auth, and Marketplace.
+              <a:t>▪ Docker Containment: Standardized local/cloud staging environments.</a:t>
+            </a:r>
+            <a:pPr indent="0" marL="0">
+              <a:buNone/>
+            </a:pPr>
+            <a:r>
+              <a:rPr lang="en-US" sz="1200" dirty="0">
+                <a:solidFill>
+                  <a:srgbClr val="000000"/>
+                </a:solidFill>
+              </a:rPr>
+              <a:t>
 </a:t>
             </a:r>
             <a:pPr indent="0" marL="0">
               <a:buNone/>
             </a:pPr>
             <a:r>
-              <a:rPr lang="en-US" sz="1400" b="1" dirty="0">
-                <a:solidFill>
-                  <a:srgbClr val="FFFFFF"/>
+              <a:rPr lang="en-US" sz="1300" dirty="0">
+                <a:solidFill>
+                  <a:srgbClr val="A0A0A0"/>
                 </a:solidFill>
                 <a:latin typeface="Inter" pitchFamily="34" charset="0"/>
                 <a:ea typeface="Inter" pitchFamily="34" charset="-122"/>
                 <a:cs typeface="Inter" pitchFamily="34" charset="-120"/>
               </a:rPr>
-              <a:t>▪  Lucide Vector Styling: </a:t>
-            </a:r>
-            <a:pPr indent="0" marL="0">
-              <a:buNone/>
-            </a:pPr>
-            <a:r>
-              <a:rPr lang="en-US" sz="1400" dirty="0">
-                <a:solidFill>
-                  <a:srgbClr val="AAAAAA"/>
+              <a:t>▪ Gateway Routing: Intermediary proxy handling CORS limits, headers, and request tracking.</a:t>
+            </a:r>
+            <a:pPr indent="0" marL="0">
+              <a:buNone/>
+            </a:pPr>
+            <a:r>
+              <a:rPr lang="en-US" sz="1200" dirty="0">
+                <a:solidFill>
+                  <a:srgbClr val="000000"/>
+                </a:solidFill>
+              </a:rPr>
+              <a:t>
+</a:t>
+            </a:r>
+            <a:pPr indent="0" marL="0">
+              <a:buNone/>
+            </a:pPr>
+            <a:r>
+              <a:rPr lang="en-US" sz="1300" dirty="0">
+                <a:solidFill>
+                  <a:srgbClr val="A0A0A0"/>
                 </a:solidFill>
                 <a:latin typeface="Inter" pitchFamily="34" charset="0"/>
                 <a:ea typeface="Inter" pitchFamily="34" charset="-122"/>
                 <a:cs typeface="Inter" pitchFamily="34" charset="-120"/>
               </a:rPr>
-              <a:t>Responsive icon integration with dynamic color mappings.</a:t>
-            </a:r>
-            <a:endParaRPr lang="en-US" sz="1400" dirty="0"/>
-          </a:p>
-        </p:txBody>
-      </p:sp>
-      <p:sp>
-        <p:nvSpPr>
-          <p:cNvPr id="4" name="Text 2"/>
-          <p:cNvSpPr/>
-          <p:nvPr/>
-        </p:nvSpPr>
-        <p:spPr>
-          <a:xfrm>
-            <a:off x="6400800" y="1645920"/>
-            <a:ext cx="4873752" cy="4572000"/>
-          </a:xfrm>
-          <a:prstGeom prst="rect">
-            <a:avLst/>
-          </a:prstGeom>
-          <a:noFill/>
-          <a:ln/>
-        </p:spPr>
-        <p:txBody>
-          <a:bodyPr wrap="square" rtlCol="0" anchor="ctr"/>
-          <a:lstStyle/>
-          <a:p>
-            <a:pPr indent="0" marL="0">
-              <a:buNone/>
-            </a:pPr>
-            <a:r>
-              <a:rPr lang="en-US" sz="2000" b="1" dirty="0">
-                <a:solidFill>
-                  <a:srgbClr val="00F3FF"/>
-                </a:solidFill>
-                <a:latin typeface="Outfit" pitchFamily="34" charset="0"/>
-                <a:ea typeface="Outfit" pitchFamily="34" charset="-122"/>
-                <a:cs typeface="Outfit" pitchFamily="34" charset="-120"/>
-              </a:rPr>
-              <a:t>BACKEND MICROSERVICES LAYER
-</a:t>
-            </a:r>
-            <a:pPr indent="0" marL="0">
-              <a:buNone/>
-            </a:pPr>
-            <a:r>
-              <a:rPr lang="en-US" sz="1400" b="1" dirty="0">
-                <a:solidFill>
-                  <a:srgbClr val="FFFFFF"/>
-                </a:solidFill>
-                <a:latin typeface="Inter" pitchFamily="34" charset="0"/>
-                <a:ea typeface="Inter" pitchFamily="34" charset="-122"/>
-                <a:cs typeface="Inter" pitchFamily="34" charset="-120"/>
-              </a:rPr>
-              <a:t>▪  Python &amp; REST APIs: </a:t>
-            </a:r>
-            <a:pPr indent="0" marL="0">
-              <a:buNone/>
-            </a:pPr>
-            <a:r>
-              <a:rPr lang="en-US" sz="1400" dirty="0">
-                <a:solidFill>
-                  <a:srgbClr val="AAAAAA"/>
-                </a:solidFill>
-                <a:latin typeface="Inter" pitchFamily="34" charset="0"/>
-                <a:ea typeface="Inter" pitchFamily="34" charset="-122"/>
-                <a:cs typeface="Inter" pitchFamily="34" charset="-120"/>
-              </a:rPr>
-              <a:t>Backend routes built for analytics models and service orchestration.
-</a:t>
-            </a:r>
-            <a:pPr indent="0" marL="0">
-              <a:buNone/>
-            </a:pPr>
-            <a:r>
-              <a:rPr lang="en-US" sz="1400" b="1" dirty="0">
-                <a:solidFill>
-                  <a:srgbClr val="FFFFFF"/>
-                </a:solidFill>
-                <a:latin typeface="Inter" pitchFamily="34" charset="0"/>
-                <a:ea typeface="Inter" pitchFamily="34" charset="-122"/>
-                <a:cs typeface="Inter" pitchFamily="34" charset="-120"/>
-              </a:rPr>
-              <a:t>▪  Docker Containers: </a:t>
-            </a:r>
-            <a:pPr indent="0" marL="0">
-              <a:buNone/>
-            </a:pPr>
-            <a:r>
-              <a:rPr lang="en-US" sz="1400" dirty="0">
-                <a:solidFill>
-                  <a:srgbClr val="AAAAAA"/>
-                </a:solidFill>
-                <a:latin typeface="Inter" pitchFamily="34" charset="0"/>
-                <a:ea typeface="Inter" pitchFamily="34" charset="-122"/>
-                <a:cs typeface="Inter" pitchFamily="34" charset="-120"/>
-              </a:rPr>
-              <a:t>Encapsulates services to guarantee consistency across environments.
-</a:t>
-            </a:r>
-            <a:pPr indent="0" marL="0">
-              <a:buNone/>
-            </a:pPr>
-            <a:r>
-              <a:rPr lang="en-US" sz="1400" b="1" dirty="0">
-                <a:solidFill>
-                  <a:srgbClr val="FFFFFF"/>
-                </a:solidFill>
-                <a:latin typeface="Inter" pitchFamily="34" charset="0"/>
-                <a:ea typeface="Inter" pitchFamily="34" charset="-122"/>
-                <a:cs typeface="Inter" pitchFamily="34" charset="-120"/>
-              </a:rPr>
-              <a:t>▪  Unified API Gateway: </a:t>
-            </a:r>
-            <a:pPr indent="0" marL="0">
-              <a:buNone/>
-            </a:pPr>
-            <a:r>
-              <a:rPr lang="en-US" sz="1400" dirty="0">
-                <a:solidFill>
-                  <a:srgbClr val="AAAAAA"/>
-                </a:solidFill>
-                <a:latin typeface="Inter" pitchFamily="34" charset="0"/>
-                <a:ea typeface="Inter" pitchFamily="34" charset="-122"/>
-                <a:cs typeface="Inter" pitchFamily="34" charset="-120"/>
-              </a:rPr>
-              <a:t>Manages central traffic routing, load-balancing, and response formats.
-</a:t>
-            </a:r>
-            <a:pPr indent="0" marL="0">
-              <a:buNone/>
-            </a:pPr>
-            <a:r>
-              <a:rPr lang="en-US" sz="1400" b="1" dirty="0">
-                <a:solidFill>
-                  <a:srgbClr val="FFFFFF"/>
-                </a:solidFill>
-                <a:latin typeface="Inter" pitchFamily="34" charset="0"/>
-                <a:ea typeface="Inter" pitchFamily="34" charset="-122"/>
-                <a:cs typeface="Inter" pitchFamily="34" charset="-120"/>
-              </a:rPr>
-              <a:t>▪  Git &amp; Version Control: </a:t>
-            </a:r>
-            <a:pPr indent="0" marL="0">
-              <a:buNone/>
-            </a:pPr>
-            <a:r>
-              <a:rPr lang="en-US" sz="1400" dirty="0">
-                <a:solidFill>
-                  <a:srgbClr val="AAAAAA"/>
-                </a:solidFill>
-                <a:latin typeface="Inter" pitchFamily="34" charset="0"/>
-                <a:ea typeface="Inter" pitchFamily="34" charset="-122"/>
-                <a:cs typeface="Inter" pitchFamily="34" charset="-120"/>
-              </a:rPr>
-              <a:t>Enables robust collaborative version workflows and branch protection.</a:t>
-            </a:r>
-            <a:endParaRPr lang="en-US" sz="1400" dirty="0"/>
+              <a:t>▪ Git &amp; GitHub: Maintained clean branch integrations for codebase safety.</a:t>
+            </a:r>
+            <a:endParaRPr lang="en-US" sz="1300" dirty="0"/>
           </a:p>
         </p:txBody>
       </p:sp>
@@ -2432,7 +3400,7 @@
     <p:bg>
       <p:bgPr>
         <a:solidFill>
-          <a:srgbClr val="0D0D0D"/>
+          <a:srgbClr val="080808"/>
         </a:solidFill>
       </p:bgPr>
     </p:bg>
@@ -2458,7 +3426,7 @@
         </p:nvSpPr>
         <p:spPr>
           <a:xfrm>
-            <a:off x="914400" y="548640"/>
+            <a:off x="914400" y="457200"/>
             <a:ext cx="10360152" cy="731520"/>
           </a:xfrm>
           <a:prstGeom prst="rect">
@@ -2475,7 +3443,7 @@
               <a:buNone/>
             </a:pPr>
             <a:r>
-              <a:rPr lang="en-US" sz="3600" b="1" dirty="0">
+              <a:rPr lang="en-US" sz="3200" b="1" dirty="0">
                 <a:solidFill>
                   <a:srgbClr val="00F3FF"/>
                 </a:solidFill>
@@ -2483,22 +3451,67 @@
                 <a:ea typeface="Outfit" pitchFamily="34" charset="-122"/>
                 <a:cs typeface="Outfit" pitchFamily="34" charset="-120"/>
               </a:rPr>
-              <a:t>Future Scope: Next-Gen Integrations</a:t>
-            </a:r>
-            <a:endParaRPr lang="en-US" sz="3600" dirty="0"/>
-          </a:p>
-        </p:txBody>
-      </p:sp>
-      <p:sp>
-        <p:nvSpPr>
-          <p:cNvPr id="3" name="Text 1"/>
+              <a:t>Future Roadmap</a:t>
+            </a:r>
+            <a:endParaRPr lang="en-US" sz="3200" dirty="0"/>
+          </a:p>
+        </p:txBody>
+      </p:sp>
+      <p:sp>
+        <p:nvSpPr>
+          <p:cNvPr id="3" name="Shape 1"/>
+          <p:cNvSpPr/>
+          <p:nvPr/>
+        </p:nvSpPr>
+        <p:spPr>
+          <a:xfrm>
+            <a:off x="914400" y="1143000"/>
+            <a:ext cx="1828800" cy="36576"/>
+          </a:xfrm>
+          <a:prstGeom prst="rect">
+            <a:avLst/>
+          </a:prstGeom>
+          <a:solidFill>
+            <a:srgbClr val="00F3FF"/>
+          </a:solidFill>
+          <a:ln/>
+        </p:spPr>
+      </p:sp>
+      <p:sp>
+        <p:nvSpPr>
+          <p:cNvPr id="4" name="Shape 2"/>
           <p:cNvSpPr/>
           <p:nvPr/>
         </p:nvSpPr>
         <p:spPr>
           <a:xfrm>
             <a:off x="914400" y="1645920"/>
-            <a:ext cx="10360152" cy="4572000"/>
+            <a:ext cx="3200400" cy="4572000"/>
+          </a:xfrm>
+          <a:prstGeom prst="roundRect">
+            <a:avLst/>
+          </a:prstGeom>
+          <a:solidFill>
+            <a:srgbClr val="121212"/>
+          </a:solidFill>
+          <a:ln w="12700">
+            <a:solidFill>
+              <a:srgbClr val="222222"/>
+            </a:solidFill>
+            <a:prstDash val="solid"/>
+          </a:ln>
+        </p:spPr>
+      </p:sp>
+      <p:sp>
+        <p:nvSpPr>
+          <p:cNvPr id="5" name="Text 3"/>
+          <p:cNvSpPr/>
+          <p:nvPr/>
+        </p:nvSpPr>
+        <p:spPr>
+          <a:xfrm>
+            <a:off x="1143000" y="1828800"/>
+            <a:ext cx="2743200" cy="365760"/>
           </a:xfrm>
           <a:prstGeom prst="rect">
             <a:avLst/>
@@ -2516,145 +3529,338 @@
             <a:r>
               <a:rPr lang="en-US" sz="1600" b="1" dirty="0">
                 <a:solidFill>
-                  <a:srgbClr val="FFFFFF"/>
+                  <a:srgbClr val="00F3FF"/>
+                </a:solidFill>
+                <a:latin typeface="Outfit" pitchFamily="34" charset="0"/>
+                <a:ea typeface="Outfit" pitchFamily="34" charset="-122"/>
+                <a:cs typeface="Outfit" pitchFamily="34" charset="-120"/>
+              </a:rPr>
+              <a:t>Phase 1: Performance Core</a:t>
+            </a:r>
+            <a:endParaRPr lang="en-US" sz="1600" dirty="0"/>
+          </a:p>
+        </p:txBody>
+      </p:sp>
+      <p:sp>
+        <p:nvSpPr>
+          <p:cNvPr id="6" name="Text 4"/>
+          <p:cNvSpPr/>
+          <p:nvPr/>
+        </p:nvSpPr>
+        <p:spPr>
+          <a:xfrm>
+            <a:off x="1143000" y="2286000"/>
+            <a:ext cx="2743200" cy="3749040"/>
+          </a:xfrm>
+          <a:prstGeom prst="rect">
+            <a:avLst/>
+          </a:prstGeom>
+          <a:noFill/>
+          <a:ln/>
+        </p:spPr>
+        <p:txBody>
+          <a:bodyPr wrap="square" rtlCol="0" anchor="t"/>
+          <a:lstStyle/>
+          <a:p>
+            <a:pPr indent="0" marL="0">
+              <a:buNone/>
+            </a:pPr>
+            <a:r>
+              <a:rPr lang="en-US" sz="1300" dirty="0">
+                <a:solidFill>
+                  <a:srgbClr val="A0A0A0"/>
                 </a:solidFill>
                 <a:latin typeface="Inter" pitchFamily="34" charset="0"/>
                 <a:ea typeface="Inter" pitchFamily="34" charset="-122"/>
                 <a:cs typeface="Inter" pitchFamily="34" charset="-120"/>
               </a:rPr>
-              <a:t>▪  Migration to Asynchronous FastAPI: </a:t>
-            </a:r>
-            <a:pPr indent="0" marL="0">
-              <a:buNone/>
-            </a:pPr>
-            <a:r>
-              <a:rPr lang="en-US" sz="1600" dirty="0">
-                <a:solidFill>
-                  <a:srgbClr val="AAAAAA"/>
+              <a:t>▪ FastAPI Migration: Port Mock backend controllers into async Python threads for high throughput.</a:t>
+            </a:r>
+            <a:pPr indent="0" marL="0">
+              <a:buNone/>
+            </a:pPr>
+            <a:r>
+              <a:rPr lang="en-US" sz="1200" dirty="0">
+                <a:solidFill>
+                  <a:srgbClr val="000000"/>
+                </a:solidFill>
+              </a:rPr>
+              <a:t>
+</a:t>
+            </a:r>
+            <a:pPr indent="0" marL="0">
+              <a:buNone/>
+            </a:pPr>
+            <a:r>
+              <a:rPr lang="en-US" sz="1300" dirty="0">
+                <a:solidFill>
+                  <a:srgbClr val="A0A0A0"/>
                 </a:solidFill>
                 <a:latin typeface="Inter" pitchFamily="34" charset="0"/>
                 <a:ea typeface="Inter" pitchFamily="34" charset="-122"/>
                 <a:cs typeface="Inter" pitchFamily="34" charset="-120"/>
               </a:rPr>
-              <a:t>Refactoring simulated API gateways into high-performance Python FastAPI worker threads to support high concurrency.
-</a:t>
-            </a:r>
+              <a:t>▪ Redis Cache: Introduce Redis cache mechanisms to manage rate limits and cache persistent payloads.</a:t>
+            </a:r>
+            <a:endParaRPr lang="en-US" sz="1300" dirty="0"/>
+          </a:p>
+        </p:txBody>
+      </p:sp>
+      <p:sp>
+        <p:nvSpPr>
+          <p:cNvPr id="7" name="Shape 5"/>
+          <p:cNvSpPr/>
+          <p:nvPr/>
+        </p:nvSpPr>
+        <p:spPr>
+          <a:xfrm>
+            <a:off x="4489704" y="1645920"/>
+            <a:ext cx="3200400" cy="4572000"/>
+          </a:xfrm>
+          <a:prstGeom prst="roundRect">
+            <a:avLst/>
+          </a:prstGeom>
+          <a:solidFill>
+            <a:srgbClr val="121212"/>
+          </a:solidFill>
+          <a:ln w="12700">
+            <a:solidFill>
+              <a:srgbClr val="222222"/>
+            </a:solidFill>
+            <a:prstDash val="solid"/>
+          </a:ln>
+        </p:spPr>
+      </p:sp>
+      <p:sp>
+        <p:nvSpPr>
+          <p:cNvPr id="8" name="Text 6"/>
+          <p:cNvSpPr/>
+          <p:nvPr/>
+        </p:nvSpPr>
+        <p:spPr>
+          <a:xfrm>
+            <a:off x="4718304" y="1828800"/>
+            <a:ext cx="2743200" cy="365760"/>
+          </a:xfrm>
+          <a:prstGeom prst="rect">
+            <a:avLst/>
+          </a:prstGeom>
+          <a:noFill/>
+          <a:ln/>
+        </p:spPr>
+        <p:txBody>
+          <a:bodyPr wrap="square" rtlCol="0" anchor="ctr"/>
+          <a:lstStyle/>
+          <a:p>
             <a:pPr indent="0" marL="0">
               <a:buNone/>
             </a:pPr>
             <a:r>
               <a:rPr lang="en-US" sz="1600" b="1" dirty="0">
                 <a:solidFill>
-                  <a:srgbClr val="FFFFFF"/>
+                  <a:srgbClr val="00F3FF"/>
+                </a:solidFill>
+                <a:latin typeface="Outfit" pitchFamily="34" charset="0"/>
+                <a:ea typeface="Outfit" pitchFamily="34" charset="-122"/>
+                <a:cs typeface="Outfit" pitchFamily="34" charset="-120"/>
+              </a:rPr>
+              <a:t>Phase 2: Secure Platform</a:t>
+            </a:r>
+            <a:endParaRPr lang="en-US" sz="1600" dirty="0"/>
+          </a:p>
+        </p:txBody>
+      </p:sp>
+      <p:sp>
+        <p:nvSpPr>
+          <p:cNvPr id="9" name="Text 7"/>
+          <p:cNvSpPr/>
+          <p:nvPr/>
+        </p:nvSpPr>
+        <p:spPr>
+          <a:xfrm>
+            <a:off x="4718304" y="2286000"/>
+            <a:ext cx="2743200" cy="3749040"/>
+          </a:xfrm>
+          <a:prstGeom prst="rect">
+            <a:avLst/>
+          </a:prstGeom>
+          <a:noFill/>
+          <a:ln/>
+        </p:spPr>
+        <p:txBody>
+          <a:bodyPr wrap="square" rtlCol="0" anchor="t"/>
+          <a:lstStyle/>
+          <a:p>
+            <a:pPr indent="0" marL="0">
+              <a:buNone/>
+            </a:pPr>
+            <a:r>
+              <a:rPr lang="en-US" sz="1300" dirty="0">
+                <a:solidFill>
+                  <a:srgbClr val="A0A0A0"/>
                 </a:solidFill>
                 <a:latin typeface="Inter" pitchFamily="34" charset="0"/>
                 <a:ea typeface="Inter" pitchFamily="34" charset="-122"/>
                 <a:cs typeface="Inter" pitchFamily="34" charset="-120"/>
               </a:rPr>
-              <a:t>▪  Redis Distributed Cache &amp; Limiter: </a:t>
-            </a:r>
-            <a:pPr indent="0" marL="0">
-              <a:buNone/>
-            </a:pPr>
-            <a:r>
-              <a:rPr lang="en-US" sz="1600" dirty="0">
-                <a:solidFill>
-                  <a:srgbClr val="AAAAAA"/>
+              <a:t>▪ Production Auth: Build OAuth 2.0 (GitHub/Google) authentication flows.</a:t>
+            </a:r>
+            <a:pPr indent="0" marL="0">
+              <a:buNone/>
+            </a:pPr>
+            <a:r>
+              <a:rPr lang="en-US" sz="1200" dirty="0">
+                <a:solidFill>
+                  <a:srgbClr val="000000"/>
+                </a:solidFill>
+              </a:rPr>
+              <a:t>
+</a:t>
+            </a:r>
+            <a:pPr indent="0" marL="0">
+              <a:buNone/>
+            </a:pPr>
+            <a:r>
+              <a:rPr lang="en-US" sz="1300" dirty="0">
+                <a:solidFill>
+                  <a:srgbClr val="A0A0A0"/>
                 </a:solidFill>
                 <a:latin typeface="Inter" pitchFamily="34" charset="0"/>
                 <a:ea typeface="Inter" pitchFamily="34" charset="-122"/>
                 <a:cs typeface="Inter" pitchFamily="34" charset="-120"/>
               </a:rPr>
-              <a:t>Moving mock rate limiters into a distributed Redis token-bucket system for reliable server protection.
-</a:t>
-            </a:r>
+              <a:t>▪ Database Sync: Deploy a secure PostgreSQL database to store and manage actual consumer metric rows.</a:t>
+            </a:r>
+            <a:endParaRPr lang="en-US" sz="1300" dirty="0"/>
+          </a:p>
+        </p:txBody>
+      </p:sp>
+      <p:sp>
+        <p:nvSpPr>
+          <p:cNvPr id="10" name="Shape 8"/>
+          <p:cNvSpPr/>
+          <p:nvPr/>
+        </p:nvSpPr>
+        <p:spPr>
+          <a:xfrm>
+            <a:off x="8065008" y="1645920"/>
+            <a:ext cx="3200400" cy="4572000"/>
+          </a:xfrm>
+          <a:prstGeom prst="roundRect">
+            <a:avLst/>
+          </a:prstGeom>
+          <a:solidFill>
+            <a:srgbClr val="121212"/>
+          </a:solidFill>
+          <a:ln w="12700">
+            <a:solidFill>
+              <a:srgbClr val="222222"/>
+            </a:solidFill>
+            <a:prstDash val="solid"/>
+          </a:ln>
+        </p:spPr>
+      </p:sp>
+      <p:sp>
+        <p:nvSpPr>
+          <p:cNvPr id="11" name="Text 9"/>
+          <p:cNvSpPr/>
+          <p:nvPr/>
+        </p:nvSpPr>
+        <p:spPr>
+          <a:xfrm>
+            <a:off x="8293608" y="1828800"/>
+            <a:ext cx="2743200" cy="365760"/>
+          </a:xfrm>
+          <a:prstGeom prst="rect">
+            <a:avLst/>
+          </a:prstGeom>
+          <a:noFill/>
+          <a:ln/>
+        </p:spPr>
+        <p:txBody>
+          <a:bodyPr wrap="square" rtlCol="0" anchor="ctr"/>
+          <a:lstStyle/>
+          <a:p>
             <a:pPr indent="0" marL="0">
               <a:buNone/>
             </a:pPr>
             <a:r>
               <a:rPr lang="en-US" sz="1600" b="1" dirty="0">
                 <a:solidFill>
-                  <a:srgbClr val="FFFFFF"/>
+                  <a:srgbClr val="00F3FF"/>
+                </a:solidFill>
+                <a:latin typeface="Outfit" pitchFamily="34" charset="0"/>
+                <a:ea typeface="Outfit" pitchFamily="34" charset="-122"/>
+                <a:cs typeface="Outfit" pitchFamily="34" charset="-120"/>
+              </a:rPr>
+              <a:t>Phase 3: Developer Utility</a:t>
+            </a:r>
+            <a:endParaRPr lang="en-US" sz="1600" dirty="0"/>
+          </a:p>
+        </p:txBody>
+      </p:sp>
+      <p:sp>
+        <p:nvSpPr>
+          <p:cNvPr id="12" name="Text 10"/>
+          <p:cNvSpPr/>
+          <p:nvPr/>
+        </p:nvSpPr>
+        <p:spPr>
+          <a:xfrm>
+            <a:off x="8293608" y="2286000"/>
+            <a:ext cx="2743200" cy="3749040"/>
+          </a:xfrm>
+          <a:prstGeom prst="rect">
+            <a:avLst/>
+          </a:prstGeom>
+          <a:noFill/>
+          <a:ln/>
+        </p:spPr>
+        <p:txBody>
+          <a:bodyPr wrap="square" rtlCol="0" anchor="t"/>
+          <a:lstStyle/>
+          <a:p>
+            <a:pPr indent="0" marL="0">
+              <a:buNone/>
+            </a:pPr>
+            <a:r>
+              <a:rPr lang="en-US" sz="1300" dirty="0">
+                <a:solidFill>
+                  <a:srgbClr val="A0A0A0"/>
                 </a:solidFill>
                 <a:latin typeface="Inter" pitchFamily="34" charset="0"/>
                 <a:ea typeface="Inter" pitchFamily="34" charset="-122"/>
                 <a:cs typeface="Inter" pitchFamily="34" charset="-120"/>
               </a:rPr>
-              <a:t>▪  Active OAuth &amp; PostgreSQL DB: </a:t>
-            </a:r>
-            <a:pPr indent="0" marL="0">
-              <a:buNone/>
-            </a:pPr>
-            <a:r>
-              <a:rPr lang="en-US" sz="1600" dirty="0">
-                <a:solidFill>
-                  <a:srgbClr val="AAAAAA"/>
+              <a:t>▪ Analytics Charts: Integrate UI charting (Recharts) inside the dashboard for requests/latency.</a:t>
+            </a:r>
+            <a:pPr indent="0" marL="0">
+              <a:buNone/>
+            </a:pPr>
+            <a:r>
+              <a:rPr lang="en-US" sz="1200" dirty="0">
+                <a:solidFill>
+                  <a:srgbClr val="000000"/>
+                </a:solidFill>
+              </a:rPr>
+              <a:t>
+</a:t>
+            </a:r>
+            <a:pPr indent="0" marL="0">
+              <a:buNone/>
+            </a:pPr>
+            <a:r>
+              <a:rPr lang="en-US" sz="1300" dirty="0">
+                <a:solidFill>
+                  <a:srgbClr val="A0A0A0"/>
                 </a:solidFill>
                 <a:latin typeface="Inter" pitchFamily="34" charset="0"/>
                 <a:ea typeface="Inter" pitchFamily="34" charset="-122"/>
                 <a:cs typeface="Inter" pitchFamily="34" charset="-120"/>
               </a:rPr>
-              <a:t>Replacing mock auth actions with production OAuth2 (GitHub/Google) and syncing stats with a secure PostgreSQL database.
-</a:t>
-            </a:r>
-            <a:pPr indent="0" marL="0">
-              <a:buNone/>
-            </a:pPr>
-            <a:r>
-              <a:rPr lang="en-US" sz="1600" b="1" dirty="0">
-                <a:solidFill>
-                  <a:srgbClr val="FFFFFF"/>
-                </a:solidFill>
-                <a:latin typeface="Inter" pitchFamily="34" charset="0"/>
-                <a:ea typeface="Inter" pitchFamily="34" charset="-122"/>
-                <a:cs typeface="Inter" pitchFamily="34" charset="-120"/>
-              </a:rPr>
-              <a:t>▪  Interactive Data Charts: </a:t>
-            </a:r>
-            <a:pPr indent="0" marL="0">
-              <a:buNone/>
-            </a:pPr>
-            <a:r>
-              <a:rPr lang="en-US" sz="1600" dirty="0">
-                <a:solidFill>
-                  <a:srgbClr val="AAAAAA"/>
-                </a:solidFill>
-                <a:latin typeface="Inter" pitchFamily="34" charset="0"/>
-                <a:ea typeface="Inter" pitchFamily="34" charset="-122"/>
-                <a:cs typeface="Inter" pitchFamily="34" charset="-120"/>
-              </a:rPr>
-              <a:t>Integrating charting tools (like Recharts) on the user Dashboard to display live API requests, latencies, and server load.
-</a:t>
-            </a:r>
-            <a:pPr indent="0" marL="0">
-              <a:buNone/>
-            </a:pPr>
-            <a:r>
-              <a:rPr lang="en-US" sz="1600" b="1" dirty="0">
-                <a:solidFill>
-                  <a:srgbClr val="FFFFFF"/>
-                </a:solidFill>
-                <a:latin typeface="Inter" pitchFamily="34" charset="0"/>
-                <a:ea typeface="Inter" pitchFamily="34" charset="-122"/>
-                <a:cs typeface="Inter" pitchFamily="34" charset="-120"/>
-              </a:rPr>
-              <a:t>▪  Auto-Generated Client SDKs: </a:t>
-            </a:r>
-            <a:pPr indent="0" marL="0">
-              <a:buNone/>
-            </a:pPr>
-            <a:r>
-              <a:rPr lang="en-US" sz="1600" dirty="0">
-                <a:solidFill>
-                  <a:srgbClr val="AAAAAA"/>
-                </a:solidFill>
-                <a:latin typeface="Inter" pitchFamily="34" charset="0"/>
-                <a:ea typeface="Inter" pitchFamily="34" charset="-122"/>
-                <a:cs typeface="Inter" pitchFamily="34" charset="-120"/>
-              </a:rPr>
-              <a:t>Providing one-click, custom-compiled client SDK download options in multiple languages (Python, Go, Node.js).</a:t>
-            </a:r>
-            <a:endParaRPr lang="en-US" sz="1600" dirty="0"/>
+              <a:t>▪ SDK Generation: Export client library SDK packages (Python/JS/Go) for sandbox integrations.</a:t>
+            </a:r>
+            <a:endParaRPr lang="en-US" sz="1300" dirty="0"/>
           </a:p>
         </p:txBody>
       </p:sp>

</xml_diff>

<commit_message>
feat: integrate AI Study Buddy flagship platform APIs and update presentation
</commit_message>
<xml_diff>
--- a/API_Marketplace_Presentation.pptx
+++ b/API_Marketplace_Presentation.pptx
@@ -11,9 +11,10 @@
     <p:sldId id="259" r:id="rId5"/>
     <p:sldId id="260" r:id="rId6"/>
     <p:sldId id="261" r:id="rId7"/>
+    <p:sldId id="262" r:id="rId8"/>
   </p:sldIdLst>
   <p:notesMasterIdLst>
-    <p:notesMasterId r:id="rId8"/>
+    <p:notesMasterId r:id="rId9"/>
   </p:notesMasterIdLst>
   <p:sldSz cx="9144000" cy="5143500"/>
   <p:notesSz cx="5143500" cy="9144000"/>
@@ -989,6 +990,94 @@
 </p:notes>
 </file>
 
+<file path=ppt/notesSlides/notesSlide7.xml><?xml version="1.0" encoding="utf-8"?>
+<p:notes xmlns:a="http://schemas.openxmlformats.org/drawingml/2006/main" xmlns:r="http://schemas.openxmlformats.org/officeDocument/2006/relationships" xmlns:p="http://schemas.openxmlformats.org/presentationml/2006/main">
+  <p:cSld>
+    <p:spTree>
+      <p:nvGrpSpPr>
+        <p:cNvPr id="1" name=""/>
+        <p:cNvGrpSpPr/>
+        <p:nvPr/>
+      </p:nvGrpSpPr>
+      <p:grpSpPr>
+        <a:xfrm>
+          <a:off x="0" y="0"/>
+          <a:ext cx="0" cy="0"/>
+          <a:chOff x="0" y="0"/>
+          <a:chExt cx="0" cy="0"/>
+        </a:xfrm>
+      </p:grpSpPr>
+      <p:sp>
+        <p:nvSpPr>
+          <p:cNvPr id="2" name="Slide Image Placeholder 1"/>
+          <p:cNvSpPr>
+            <a:spLocks noGrp="1" noRot="1" noChangeAspect="1"/>
+          </p:cNvSpPr>
+          <p:nvPr>
+            <p:ph type="sldImg"/>
+          </p:nvPr>
+        </p:nvSpPr>
+        <p:spPr/>
+      </p:sp>
+      <p:sp>
+        <p:nvSpPr>
+          <p:cNvPr id="3" name="Notes Placeholder 2"/>
+          <p:cNvSpPr>
+            <a:spLocks noGrp="1"/>
+          </p:cNvSpPr>
+          <p:nvPr>
+            <p:ph type="body" idx="1"/>
+          </p:nvPr>
+        </p:nvSpPr>
+        <p:spPr/>
+        <p:txBody>
+          <a:bodyPr/>
+          <a:lstStyle/>
+          <a:p>
+            <a:r>
+              <a:rPr lang="en-US" dirty="0"/>
+              <a:t/>
+            </a:r>
+            <a:endParaRPr lang="en-US" dirty="0"/>
+          </a:p>
+        </p:txBody>
+      </p:sp>
+      <p:sp>
+        <p:nvSpPr>
+          <p:cNvPr id="4" name="Slide Number Placeholder 3"/>
+          <p:cNvSpPr>
+            <a:spLocks noGrp="1"/>
+          </p:cNvSpPr>
+          <p:nvPr>
+            <p:ph type="sldNum" sz="quarter" idx="10"/>
+          </p:nvPr>
+        </p:nvSpPr>
+        <p:spPr/>
+        <p:txBody>
+          <a:bodyPr/>
+          <a:lstStyle/>
+          <a:p>
+            <a:fld id="{F7021451-1387-4CA6-816F-3879F97B5CBC}" type="slidenum">
+              <a:rPr lang="en-US"/>
+              <a:t>7</a:t>
+            </a:fld>
+            <a:endParaRPr lang="en-US"/>
+          </a:p>
+        </p:txBody>
+      </p:sp>
+    </p:spTree>
+    <p:extLst>
+      <p:ext uri="{BB962C8B-B14F-4D97-AF65-F5344CB8AC3E}">
+        <p14:creationId xmlns:p14="http://schemas.microsoft.com/office/powerpoint/2010/main" val="1024086991"/>
+      </p:ext>
+    </p:extLst>
+  </p:cSld>
+  <p:clrMapOvr>
+    <a:masterClrMapping/>
+  </p:clrMapOvr>
+</p:notes>
+</file>
+
 <file path=ppt/slideLayouts/slideLayout1.xml><?xml version="1.0" encoding="utf-8"?>
 <p:sldLayout xmlns:a="http://schemas.openxmlformats.org/drawingml/2006/main" xmlns:r="http://schemas.openxmlformats.org/officeDocument/2006/relationships" xmlns:p="http://schemas.openxmlformats.org/presentationml/2006/main" preserve="1">
   <p:cSld name="DEFAULT">
@@ -2721,7 +2810,7 @@
                 <a:ea typeface="Inter" pitchFamily="34" charset="-122"/>
                 <a:cs typeface="Inter" pitchFamily="34" charset="-120"/>
               </a:rPr>
-              <a:t>Directly aggregates Karthikeya's 'AI ROI Performance Analyzer' to run predictive insight queries in real time.</a:t>
+              <a:t>Directly integrates Karthikeya's flagship 'AI Study Buddy' academic assistant and 'AI ROI Performance Analyzer' into the live sandbox.</a:t>
             </a:r>
             <a:endParaRPr lang="en-US" sz="1300" dirty="0"/>
           </a:p>
@@ -2998,7 +3087,7 @@
                 <a:ea typeface="Outfit" pitchFamily="34" charset="-122"/>
                 <a:cs typeface="Outfit" pitchFamily="34" charset="-120"/>
               </a:rPr>
-              <a:t>Technical Architecture &amp; Stack</a:t>
+              <a:t>Flagship Integration: AI Study Buddy</a:t>
             </a:r>
             <a:endParaRPr lang="en-US" sz="3200" dirty="0"/>
           </a:p>
@@ -3082,7 +3171,7 @@
                 <a:ea typeface="Outfit" pitchFamily="34" charset="-122"/>
                 <a:cs typeface="Outfit" pitchFamily="34" charset="-120"/>
               </a:rPr>
-              <a:t>Frontend Presentation Layer</a:t>
+              <a:t>Smart Academic Sidekick</a:t>
             </a:r>
             <a:endParaRPr lang="en-US" sz="1600" dirty="0"/>
           </a:p>
@@ -3121,7 +3210,7 @@
                 <a:ea typeface="Inter" pitchFamily="34" charset="-122"/>
                 <a:cs typeface="Inter" pitchFamily="34" charset="-120"/>
               </a:rPr>
-              <a:t>▪ React.js (Vite): Modular UI structure ensuring fast single-page app loading.</a:t>
+              <a:t>▪ Personalised Roadmaps: Generates daily/weekly study targets and career strategy by branch and goals.</a:t>
             </a:r>
             <a:pPr indent="0" marL="0">
               <a:buNone/>
@@ -3147,7 +3236,7 @@
                 <a:ea typeface="Inter" pitchFamily="34" charset="-122"/>
                 <a:cs typeface="Inter" pitchFamily="34" charset="-120"/>
               </a:rPr>
-              <a:t>▪ Vanilla CSS System: Flexible styling representing glows, card borders, and dark mode layouts.</a:t>
+              <a:t>▪ Concept Explainer: Translates complex programming/OS topics into beginner-friendly analogies and code blocks.</a:t>
             </a:r>
             <a:pPr indent="0" marL="0">
               <a:buNone/>
@@ -3173,7 +3262,7 @@
                 <a:ea typeface="Inter" pitchFamily="34" charset="-122"/>
                 <a:cs typeface="Inter" pitchFamily="34" charset="-120"/>
               </a:rPr>
-              <a:t>▪ State Router: Seamless navigation across Dashboard, Auth dashboard, and API detailed logs.</a:t>
+              <a:t>▪ Placement Assistant: Dynamic quiz generator, ATS resume review, and tailored mock interviews.</a:t>
             </a:r>
             <a:pPr indent="0" marL="0">
               <a:buNone/>
@@ -3199,7 +3288,7 @@
                 <a:ea typeface="Inter" pitchFamily="34" charset="-122"/>
                 <a:cs typeface="Inter" pitchFamily="34" charset="-120"/>
               </a:rPr>
-              <a:t>▪ Lucide Icons: Glowing cyan vector representations.</a:t>
+              <a:t>▪ Gamified Tracker: Tracks study hours and streaks using RPG style experience points (XP) and level metrics.</a:t>
             </a:r>
             <a:endParaRPr lang="en-US" sz="1300" dirty="0"/>
           </a:p>
@@ -3263,7 +3352,7 @@
                 <a:ea typeface="Outfit" pitchFamily="34" charset="-122"/>
                 <a:cs typeface="Outfit" pitchFamily="34" charset="-120"/>
               </a:rPr>
-              <a:t>Backend Microservices Layer</a:t>
+              <a:t>Developer API Ecosystem</a:t>
             </a:r>
             <a:endParaRPr lang="en-US" sz="1600" dirty="0"/>
           </a:p>
@@ -3302,7 +3391,7 @@
                 <a:ea typeface="Inter" pitchFamily="34" charset="-122"/>
                 <a:cs typeface="Inter" pitchFamily="34" charset="-120"/>
               </a:rPr>
-              <a:t>▪ Python &amp; Node.js: High efficiency controllers and modular API servers.</a:t>
+              <a:t>▪ Developer Ready: Exposes 7 production-grade REST endpoints including roadmap, explain, and review.</a:t>
             </a:r>
             <a:pPr indent="0" marL="0">
               <a:buNone/>
@@ -3328,7 +3417,7 @@
                 <a:ea typeface="Inter" pitchFamily="34" charset="-122"/>
                 <a:cs typeface="Inter" pitchFamily="34" charset="-120"/>
               </a:rPr>
-              <a:t>▪ Docker Containment: Standardized local/cloud staging environments.</a:t>
+              <a:t>▪ Live Playground: Test endpoints inside the terminal simulator and inspect formatted JSON outputs.</a:t>
             </a:r>
             <a:pPr indent="0" marL="0">
               <a:buNone/>
@@ -3354,33 +3443,7 @@
                 <a:ea typeface="Inter" pitchFamily="34" charset="-122"/>
                 <a:cs typeface="Inter" pitchFamily="34" charset="-120"/>
               </a:rPr>
-              <a:t>▪ Gateway Routing: Intermediary proxy handling CORS limits, headers, and request tracking.</a:t>
-            </a:r>
-            <a:pPr indent="0" marL="0">
-              <a:buNone/>
-            </a:pPr>
-            <a:r>
-              <a:rPr lang="en-US" sz="1200" dirty="0">
-                <a:solidFill>
-                  <a:srgbClr val="000000"/>
-                </a:solidFill>
-              </a:rPr>
-              <a:t>
-</a:t>
-            </a:r>
-            <a:pPr indent="0" marL="0">
-              <a:buNone/>
-            </a:pPr>
-            <a:r>
-              <a:rPr lang="en-US" sz="1300" dirty="0">
-                <a:solidFill>
-                  <a:srgbClr val="A0A0A0"/>
-                </a:solidFill>
-                <a:latin typeface="Inter" pitchFamily="34" charset="0"/>
-                <a:ea typeface="Inter" pitchFamily="34" charset="-122"/>
-                <a:cs typeface="Inter" pitchFamily="34" charset="-120"/>
-              </a:rPr>
-              <a:t>▪ Git &amp; GitHub: Maintained clean branch integrations for codebase safety.</a:t>
+              <a:t>▪ SaaS Monetization: Clean developer architecture built to restrict tokens, log usage, and charge subscriptions.</a:t>
             </a:r>
             <a:endParaRPr lang="en-US" sz="1300" dirty="0"/>
           </a:p>
@@ -3451,7 +3514,7 @@
                 <a:ea typeface="Outfit" pitchFamily="34" charset="-122"/>
                 <a:cs typeface="Outfit" pitchFamily="34" charset="-120"/>
               </a:rPr>
-              <a:t>Future Roadmap</a:t>
+              <a:t>Technical Architecture &amp; Stack</a:t>
             </a:r>
             <a:endParaRPr lang="en-US" sz="3200" dirty="0"/>
           </a:p>
@@ -3486,7 +3549,7 @@
         <p:spPr>
           <a:xfrm>
             <a:off x="914400" y="1645920"/>
-            <a:ext cx="3200400" cy="4572000"/>
+            <a:ext cx="4937760" cy="4572000"/>
           </a:xfrm>
           <a:prstGeom prst="roundRect">
             <a:avLst/>
@@ -3511,7 +3574,7 @@
         <p:spPr>
           <a:xfrm>
             <a:off x="1143000" y="1828800"/>
-            <a:ext cx="2743200" cy="365760"/>
+            <a:ext cx="4480560" cy="365760"/>
           </a:xfrm>
           <a:prstGeom prst="rect">
             <a:avLst/>
@@ -3535,7 +3598,7 @@
                 <a:ea typeface="Outfit" pitchFamily="34" charset="-122"/>
                 <a:cs typeface="Outfit" pitchFamily="34" charset="-120"/>
               </a:rPr>
-              <a:t>Phase 1: Performance Core</a:t>
+              <a:t>Frontend Presentation Layer</a:t>
             </a:r>
             <a:endParaRPr lang="en-US" sz="1600" dirty="0"/>
           </a:p>
@@ -3550,7 +3613,7 @@
         <p:spPr>
           <a:xfrm>
             <a:off x="1143000" y="2286000"/>
-            <a:ext cx="2743200" cy="3749040"/>
+            <a:ext cx="4480560" cy="3749040"/>
           </a:xfrm>
           <a:prstGeom prst="rect">
             <a:avLst/>
@@ -3574,7 +3637,7 @@
                 <a:ea typeface="Inter" pitchFamily="34" charset="-122"/>
                 <a:cs typeface="Inter" pitchFamily="34" charset="-120"/>
               </a:rPr>
-              <a:t>▪ FastAPI Migration: Port Mock backend controllers into async Python threads for high throughput.</a:t>
+              <a:t>▪ React.js (Vite): Modular SPA layout ensuring instant client loading and transitions.</a:t>
             </a:r>
             <a:pPr indent="0" marL="0">
               <a:buNone/>
@@ -3600,7 +3663,59 @@
                 <a:ea typeface="Inter" pitchFamily="34" charset="-122"/>
                 <a:cs typeface="Inter" pitchFamily="34" charset="-120"/>
               </a:rPr>
-              <a:t>▪ Redis Cache: Introduce Redis cache mechanisms to manage rate limits and cache persistent payloads.</a:t>
+              <a:t>▪ Vanilla CSS System: Elegant grayscale aesthetics with custom glassmorphism and glowing neon accents.</a:t>
+            </a:r>
+            <a:pPr indent="0" marL="0">
+              <a:buNone/>
+            </a:pPr>
+            <a:r>
+              <a:rPr lang="en-US" sz="1200" dirty="0">
+                <a:solidFill>
+                  <a:srgbClr val="000000"/>
+                </a:solidFill>
+              </a:rPr>
+              <a:t>
+</a:t>
+            </a:r>
+            <a:pPr indent="0" marL="0">
+              <a:buNone/>
+            </a:pPr>
+            <a:r>
+              <a:rPr lang="en-US" sz="1300" dirty="0">
+                <a:solidFill>
+                  <a:srgbClr val="A0A0A0"/>
+                </a:solidFill>
+                <a:latin typeface="Inter" pitchFamily="34" charset="0"/>
+                <a:ea typeface="Inter" pitchFamily="34" charset="-122"/>
+                <a:cs typeface="Inter" pitchFamily="34" charset="-120"/>
+              </a:rPr>
+              <a:t>▪ State Router: Secure route protection for dashboards and auth.</a:t>
+            </a:r>
+            <a:pPr indent="0" marL="0">
+              <a:buNone/>
+            </a:pPr>
+            <a:r>
+              <a:rPr lang="en-US" sz="1200" dirty="0">
+                <a:solidFill>
+                  <a:srgbClr val="000000"/>
+                </a:solidFill>
+              </a:rPr>
+              <a:t>
+</a:t>
+            </a:r>
+            <a:pPr indent="0" marL="0">
+              <a:buNone/>
+            </a:pPr>
+            <a:r>
+              <a:rPr lang="en-US" sz="1300" dirty="0">
+                <a:solidFill>
+                  <a:srgbClr val="A0A0A0"/>
+                </a:solidFill>
+                <a:latin typeface="Inter" pitchFamily="34" charset="0"/>
+                <a:ea typeface="Inter" pitchFamily="34" charset="-122"/>
+                <a:cs typeface="Inter" pitchFamily="34" charset="-120"/>
+              </a:rPr>
+              <a:t>▪ Lucide &amp; Framer Motion: Polished vectors and responsive micro-animations.</a:t>
             </a:r>
             <a:endParaRPr lang="en-US" sz="1300" dirty="0"/>
           </a:p>
@@ -3614,8 +3729,8 @@
         </p:nvSpPr>
         <p:spPr>
           <a:xfrm>
-            <a:off x="4489704" y="1645920"/>
-            <a:ext cx="3200400" cy="4572000"/>
+            <a:off x="6336792" y="1645920"/>
+            <a:ext cx="4937760" cy="4572000"/>
           </a:xfrm>
           <a:prstGeom prst="roundRect">
             <a:avLst/>
@@ -3639,8 +3754,8 @@
         </p:nvSpPr>
         <p:spPr>
           <a:xfrm>
-            <a:off x="4718304" y="1828800"/>
-            <a:ext cx="2743200" cy="365760"/>
+            <a:off x="6565392" y="1828800"/>
+            <a:ext cx="4480560" cy="365760"/>
           </a:xfrm>
           <a:prstGeom prst="rect">
             <a:avLst/>
@@ -3664,7 +3779,7 @@
                 <a:ea typeface="Outfit" pitchFamily="34" charset="-122"/>
                 <a:cs typeface="Outfit" pitchFamily="34" charset="-120"/>
               </a:rPr>
-              <a:t>Phase 2: Secure Platform</a:t>
+              <a:t>Backend Microservices Layer</a:t>
             </a:r>
             <a:endParaRPr lang="en-US" sz="1600" dirty="0"/>
           </a:p>
@@ -3678,8 +3793,8 @@
         </p:nvSpPr>
         <p:spPr>
           <a:xfrm>
-            <a:off x="4718304" y="2286000"/>
-            <a:ext cx="2743200" cy="3749040"/>
+            <a:off x="6565392" y="2286000"/>
+            <a:ext cx="4480560" cy="3749040"/>
           </a:xfrm>
           <a:prstGeom prst="rect">
             <a:avLst/>
@@ -3703,7 +3818,7 @@
                 <a:ea typeface="Inter" pitchFamily="34" charset="-122"/>
                 <a:cs typeface="Inter" pitchFamily="34" charset="-120"/>
               </a:rPr>
-              <a:t>▪ Production Auth: Build OAuth 2.0 (GitHub/Google) authentication flows.</a:t>
+              <a:t>▪ Node.js &amp; Express: Consolidated server router serving client pages and routes.</a:t>
             </a:r>
             <a:pPr indent="0" marL="0">
               <a:buNone/>
@@ -3729,21 +3844,164 @@
                 <a:ea typeface="Inter" pitchFamily="34" charset="-122"/>
                 <a:cs typeface="Inter" pitchFamily="34" charset="-120"/>
               </a:rPr>
-              <a:t>▪ Database Sync: Deploy a secure PostgreSQL database to store and manage actual consumer metric rows.</a:t>
+              <a:t>▪ Mock AI Services: Robust handlers returning customized responses for roadmaps, reviews, and quizzes.</a:t>
+            </a:r>
+            <a:pPr indent="0" marL="0">
+              <a:buNone/>
+            </a:pPr>
+            <a:r>
+              <a:rPr lang="en-US" sz="1200" dirty="0">
+                <a:solidFill>
+                  <a:srgbClr val="000000"/>
+                </a:solidFill>
+              </a:rPr>
+              <a:t>
+</a:t>
+            </a:r>
+            <a:pPr indent="0" marL="0">
+              <a:buNone/>
+            </a:pPr>
+            <a:r>
+              <a:rPr lang="en-US" sz="1300" dirty="0">
+                <a:solidFill>
+                  <a:srgbClr val="A0A0A0"/>
+                </a:solidFill>
+                <a:latin typeface="Inter" pitchFamily="34" charset="0"/>
+                <a:ea typeface="Inter" pitchFamily="34" charset="-122"/>
+                <a:cs typeface="Inter" pitchFamily="34" charset="-120"/>
+              </a:rPr>
+              <a:t>▪ Database Schema: Designed with MongoDB schema patterns for future user-data persistence.</a:t>
+            </a:r>
+            <a:pPr indent="0" marL="0">
+              <a:buNone/>
+            </a:pPr>
+            <a:r>
+              <a:rPr lang="en-US" sz="1200" dirty="0">
+                <a:solidFill>
+                  <a:srgbClr val="000000"/>
+                </a:solidFill>
+              </a:rPr>
+              <a:t>
+</a:t>
+            </a:r>
+            <a:pPr indent="0" marL="0">
+              <a:buNone/>
+            </a:pPr>
+            <a:r>
+              <a:rPr lang="en-US" sz="1300" dirty="0">
+                <a:solidFill>
+                  <a:srgbClr val="A0A0A0"/>
+                </a:solidFill>
+                <a:latin typeface="Inter" pitchFamily="34" charset="0"/>
+                <a:ea typeface="Inter" pitchFamily="34" charset="-122"/>
+                <a:cs typeface="Inter" pitchFamily="34" charset="-120"/>
+              </a:rPr>
+              <a:t>▪ Git &amp; GitHub: Maintained clean branch integrations for codebase safety.</a:t>
             </a:r>
             <a:endParaRPr lang="en-US" sz="1300" dirty="0"/>
           </a:p>
         </p:txBody>
       </p:sp>
-      <p:sp>
-        <p:nvSpPr>
-          <p:cNvPr id="10" name="Shape 8"/>
-          <p:cNvSpPr/>
-          <p:nvPr/>
-        </p:nvSpPr>
-        <p:spPr>
-          <a:xfrm>
-            <a:off x="8065008" y="1645920"/>
+    </p:spTree>
+  </p:cSld>
+  <p:clrMapOvr>
+    <a:masterClrMapping/>
+  </p:clrMapOvr>
+</p:sld>
+</file>
+
+<file path=ppt/slides/slide7.xml><?xml version="1.0" encoding="utf-8"?>
+<p:sld xmlns:a="http://schemas.openxmlformats.org/drawingml/2006/main" xmlns:r="http://schemas.openxmlformats.org/officeDocument/2006/relationships" xmlns:p="http://schemas.openxmlformats.org/presentationml/2006/main">
+  <p:cSld name="Slide 7">
+    <p:bg>
+      <p:bgPr>
+        <a:solidFill>
+          <a:srgbClr val="080808"/>
+        </a:solidFill>
+      </p:bgPr>
+    </p:bg>
+    <p:spTree>
+      <p:nvGrpSpPr>
+        <p:cNvPr id="1" name=""/>
+        <p:cNvGrpSpPr/>
+        <p:nvPr/>
+      </p:nvGrpSpPr>
+      <p:grpSpPr>
+        <a:xfrm>
+          <a:off x="0" y="0"/>
+          <a:ext cx="0" cy="0"/>
+          <a:chOff x="0" y="0"/>
+          <a:chExt cx="0" cy="0"/>
+        </a:xfrm>
+      </p:grpSpPr>
+      <p:sp>
+        <p:nvSpPr>
+          <p:cNvPr id="2" name="Text 0"/>
+          <p:cNvSpPr/>
+          <p:nvPr/>
+        </p:nvSpPr>
+        <p:spPr>
+          <a:xfrm>
+            <a:off x="914400" y="457200"/>
+            <a:ext cx="10360152" cy="731520"/>
+          </a:xfrm>
+          <a:prstGeom prst="rect">
+            <a:avLst/>
+          </a:prstGeom>
+          <a:noFill/>
+          <a:ln/>
+        </p:spPr>
+        <p:txBody>
+          <a:bodyPr wrap="square" rtlCol="0" anchor="ctr"/>
+          <a:lstStyle/>
+          <a:p>
+            <a:pPr indent="0" marL="0">
+              <a:buNone/>
+            </a:pPr>
+            <a:r>
+              <a:rPr lang="en-US" sz="3200" b="1" dirty="0">
+                <a:solidFill>
+                  <a:srgbClr val="00F3FF"/>
+                </a:solidFill>
+                <a:latin typeface="Outfit" pitchFamily="34" charset="0"/>
+                <a:ea typeface="Outfit" pitchFamily="34" charset="-122"/>
+                <a:cs typeface="Outfit" pitchFamily="34" charset="-120"/>
+              </a:rPr>
+              <a:t>Future Roadmap</a:t>
+            </a:r>
+            <a:endParaRPr lang="en-US" sz="3200" dirty="0"/>
+          </a:p>
+        </p:txBody>
+      </p:sp>
+      <p:sp>
+        <p:nvSpPr>
+          <p:cNvPr id="3" name="Shape 1"/>
+          <p:cNvSpPr/>
+          <p:nvPr/>
+        </p:nvSpPr>
+        <p:spPr>
+          <a:xfrm>
+            <a:off x="914400" y="1143000"/>
+            <a:ext cx="1828800" cy="36576"/>
+          </a:xfrm>
+          <a:prstGeom prst="rect">
+            <a:avLst/>
+          </a:prstGeom>
+          <a:solidFill>
+            <a:srgbClr val="00F3FF"/>
+          </a:solidFill>
+          <a:ln/>
+        </p:spPr>
+      </p:sp>
+      <p:sp>
+        <p:nvSpPr>
+          <p:cNvPr id="4" name="Shape 2"/>
+          <p:cNvSpPr/>
+          <p:nvPr/>
+        </p:nvSpPr>
+        <p:spPr>
+          <a:xfrm>
+            <a:off x="914400" y="1645920"/>
             <a:ext cx="3200400" cy="4572000"/>
           </a:xfrm>
           <a:prstGeom prst="roundRect">
@@ -3762,13 +4020,13 @@
       </p:sp>
       <p:sp>
         <p:nvSpPr>
-          <p:cNvPr id="11" name="Text 9"/>
-          <p:cNvSpPr/>
-          <p:nvPr/>
-        </p:nvSpPr>
-        <p:spPr>
-          <a:xfrm>
-            <a:off x="8293608" y="1828800"/>
+          <p:cNvPr id="5" name="Text 3"/>
+          <p:cNvSpPr/>
+          <p:nvPr/>
+        </p:nvSpPr>
+        <p:spPr>
+          <a:xfrm>
+            <a:off x="1143000" y="1828800"/>
             <a:ext cx="2743200" cy="365760"/>
           </a:xfrm>
           <a:prstGeom prst="rect">
@@ -3793,7 +4051,7 @@
                 <a:ea typeface="Outfit" pitchFamily="34" charset="-122"/>
                 <a:cs typeface="Outfit" pitchFamily="34" charset="-120"/>
               </a:rPr>
-              <a:t>Phase 3: Developer Utility</a:t>
+              <a:t>Phase 1: Performance Core</a:t>
             </a:r>
             <a:endParaRPr lang="en-US" sz="1600" dirty="0"/>
           </a:p>
@@ -3801,13 +4059,13 @@
       </p:sp>
       <p:sp>
         <p:nvSpPr>
-          <p:cNvPr id="12" name="Text 10"/>
-          <p:cNvSpPr/>
-          <p:nvPr/>
-        </p:nvSpPr>
-        <p:spPr>
-          <a:xfrm>
-            <a:off x="8293608" y="2286000"/>
+          <p:cNvPr id="6" name="Text 4"/>
+          <p:cNvSpPr/>
+          <p:nvPr/>
+        </p:nvSpPr>
+        <p:spPr>
+          <a:xfrm>
+            <a:off x="1143000" y="2286000"/>
             <a:ext cx="2743200" cy="3749040"/>
           </a:xfrm>
           <a:prstGeom prst="rect">
@@ -3832,7 +4090,7 @@
                 <a:ea typeface="Inter" pitchFamily="34" charset="-122"/>
                 <a:cs typeface="Inter" pitchFamily="34" charset="-120"/>
               </a:rPr>
-              <a:t>▪ Analytics Charts: Integrate UI charting (Recharts) inside the dashboard for requests/latency.</a:t>
+              <a:t>▪ FastAPI Migration: Port proxy routers to asynchronous Python workers.</a:t>
             </a:r>
             <a:pPr indent="0" marL="0">
               <a:buNone/>
@@ -3858,7 +4116,265 @@
                 <a:ea typeface="Inter" pitchFamily="34" charset="-122"/>
                 <a:cs typeface="Inter" pitchFamily="34" charset="-120"/>
               </a:rPr>
-              <a:t>▪ SDK Generation: Export client library SDK packages (Python/JS/Go) for sandbox integrations.</a:t>
+              <a:t>▪ Redis Cache: Cache frequent roadmap queries for sub-millisecond responses.</a:t>
+            </a:r>
+            <a:endParaRPr lang="en-US" sz="1300" dirty="0"/>
+          </a:p>
+        </p:txBody>
+      </p:sp>
+      <p:sp>
+        <p:nvSpPr>
+          <p:cNvPr id="7" name="Shape 5"/>
+          <p:cNvSpPr/>
+          <p:nvPr/>
+        </p:nvSpPr>
+        <p:spPr>
+          <a:xfrm>
+            <a:off x="4489704" y="1645920"/>
+            <a:ext cx="3200400" cy="4572000"/>
+          </a:xfrm>
+          <a:prstGeom prst="roundRect">
+            <a:avLst/>
+          </a:prstGeom>
+          <a:solidFill>
+            <a:srgbClr val="121212"/>
+          </a:solidFill>
+          <a:ln w="12700">
+            <a:solidFill>
+              <a:srgbClr val="222222"/>
+            </a:solidFill>
+            <a:prstDash val="solid"/>
+          </a:ln>
+        </p:spPr>
+      </p:sp>
+      <p:sp>
+        <p:nvSpPr>
+          <p:cNvPr id="8" name="Text 6"/>
+          <p:cNvSpPr/>
+          <p:nvPr/>
+        </p:nvSpPr>
+        <p:spPr>
+          <a:xfrm>
+            <a:off x="4718304" y="1828800"/>
+            <a:ext cx="2743200" cy="365760"/>
+          </a:xfrm>
+          <a:prstGeom prst="rect">
+            <a:avLst/>
+          </a:prstGeom>
+          <a:noFill/>
+          <a:ln/>
+        </p:spPr>
+        <p:txBody>
+          <a:bodyPr wrap="square" rtlCol="0" anchor="ctr"/>
+          <a:lstStyle/>
+          <a:p>
+            <a:pPr indent="0" marL="0">
+              <a:buNone/>
+            </a:pPr>
+            <a:r>
+              <a:rPr lang="en-US" sz="1600" b="1" dirty="0">
+                <a:solidFill>
+                  <a:srgbClr val="00F3FF"/>
+                </a:solidFill>
+                <a:latin typeface="Outfit" pitchFamily="34" charset="0"/>
+                <a:ea typeface="Outfit" pitchFamily="34" charset="-122"/>
+                <a:cs typeface="Outfit" pitchFamily="34" charset="-120"/>
+              </a:rPr>
+              <a:t>Phase 2: Secure Platform</a:t>
+            </a:r>
+            <a:endParaRPr lang="en-US" sz="1600" dirty="0"/>
+          </a:p>
+        </p:txBody>
+      </p:sp>
+      <p:sp>
+        <p:nvSpPr>
+          <p:cNvPr id="9" name="Text 7"/>
+          <p:cNvSpPr/>
+          <p:nvPr/>
+        </p:nvSpPr>
+        <p:spPr>
+          <a:xfrm>
+            <a:off x="4718304" y="2286000"/>
+            <a:ext cx="2743200" cy="3749040"/>
+          </a:xfrm>
+          <a:prstGeom prst="rect">
+            <a:avLst/>
+          </a:prstGeom>
+          <a:noFill/>
+          <a:ln/>
+        </p:spPr>
+        <p:txBody>
+          <a:bodyPr wrap="square" rtlCol="0" anchor="t"/>
+          <a:lstStyle/>
+          <a:p>
+            <a:pPr indent="0" marL="0">
+              <a:buNone/>
+            </a:pPr>
+            <a:r>
+              <a:rPr lang="en-US" sz="1300" dirty="0">
+                <a:solidFill>
+                  <a:srgbClr val="A0A0A0"/>
+                </a:solidFill>
+                <a:latin typeface="Inter" pitchFamily="34" charset="0"/>
+                <a:ea typeface="Inter" pitchFamily="34" charset="-122"/>
+                <a:cs typeface="Inter" pitchFamily="34" charset="-120"/>
+              </a:rPr>
+              <a:t>▪ MongoDB Storage: Integrate database rows to store actual student profiles, streaks, and codes.</a:t>
+            </a:r>
+            <a:pPr indent="0" marL="0">
+              <a:buNone/>
+            </a:pPr>
+            <a:r>
+              <a:rPr lang="en-US" sz="1200" dirty="0">
+                <a:solidFill>
+                  <a:srgbClr val="000000"/>
+                </a:solidFill>
+              </a:rPr>
+              <a:t>
+</a:t>
+            </a:r>
+            <a:pPr indent="0" marL="0">
+              <a:buNone/>
+            </a:pPr>
+            <a:r>
+              <a:rPr lang="en-US" sz="1300" dirty="0">
+                <a:solidFill>
+                  <a:srgbClr val="A0A0A0"/>
+                </a:solidFill>
+                <a:latin typeface="Inter" pitchFamily="34" charset="0"/>
+                <a:ea typeface="Inter" pitchFamily="34" charset="-122"/>
+                <a:cs typeface="Inter" pitchFamily="34" charset="-120"/>
+              </a:rPr>
+              <a:t>▪ Real-Time Rooms: Implement Socket.io study rooms and collaborative boards.</a:t>
+            </a:r>
+            <a:endParaRPr lang="en-US" sz="1300" dirty="0"/>
+          </a:p>
+        </p:txBody>
+      </p:sp>
+      <p:sp>
+        <p:nvSpPr>
+          <p:cNvPr id="10" name="Shape 8"/>
+          <p:cNvSpPr/>
+          <p:nvPr/>
+        </p:nvSpPr>
+        <p:spPr>
+          <a:xfrm>
+            <a:off x="8065008" y="1645920"/>
+            <a:ext cx="3200400" cy="4572000"/>
+          </a:xfrm>
+          <a:prstGeom prst="roundRect">
+            <a:avLst/>
+          </a:prstGeom>
+          <a:solidFill>
+            <a:srgbClr val="121212"/>
+          </a:solidFill>
+          <a:ln w="12700">
+            <a:solidFill>
+              <a:srgbClr val="222222"/>
+            </a:solidFill>
+            <a:prstDash val="solid"/>
+          </a:ln>
+        </p:spPr>
+      </p:sp>
+      <p:sp>
+        <p:nvSpPr>
+          <p:cNvPr id="11" name="Text 9"/>
+          <p:cNvSpPr/>
+          <p:nvPr/>
+        </p:nvSpPr>
+        <p:spPr>
+          <a:xfrm>
+            <a:off x="8293608" y="1828800"/>
+            <a:ext cx="2743200" cy="365760"/>
+          </a:xfrm>
+          <a:prstGeom prst="rect">
+            <a:avLst/>
+          </a:prstGeom>
+          <a:noFill/>
+          <a:ln/>
+        </p:spPr>
+        <p:txBody>
+          <a:bodyPr wrap="square" rtlCol="0" anchor="ctr"/>
+          <a:lstStyle/>
+          <a:p>
+            <a:pPr indent="0" marL="0">
+              <a:buNone/>
+            </a:pPr>
+            <a:r>
+              <a:rPr lang="en-US" sz="1600" b="1" dirty="0">
+                <a:solidFill>
+                  <a:srgbClr val="00F3FF"/>
+                </a:solidFill>
+                <a:latin typeface="Outfit" pitchFamily="34" charset="0"/>
+                <a:ea typeface="Outfit" pitchFamily="34" charset="-122"/>
+                <a:cs typeface="Outfit" pitchFamily="34" charset="-120"/>
+              </a:rPr>
+              <a:t>Phase 3: Advanced AI features</a:t>
+            </a:r>
+            <a:endParaRPr lang="en-US" sz="1600" dirty="0"/>
+          </a:p>
+        </p:txBody>
+      </p:sp>
+      <p:sp>
+        <p:nvSpPr>
+          <p:cNvPr id="12" name="Text 10"/>
+          <p:cNvSpPr/>
+          <p:nvPr/>
+        </p:nvSpPr>
+        <p:spPr>
+          <a:xfrm>
+            <a:off x="8293608" y="2286000"/>
+            <a:ext cx="2743200" cy="3749040"/>
+          </a:xfrm>
+          <a:prstGeom prst="rect">
+            <a:avLst/>
+          </a:prstGeom>
+          <a:noFill/>
+          <a:ln/>
+        </p:spPr>
+        <p:txBody>
+          <a:bodyPr wrap="square" rtlCol="0" anchor="t"/>
+          <a:lstStyle/>
+          <a:p>
+            <a:pPr indent="0" marL="0">
+              <a:buNone/>
+            </a:pPr>
+            <a:r>
+              <a:rPr lang="en-US" sz="1300" dirty="0">
+                <a:solidFill>
+                  <a:srgbClr val="A0A0A0"/>
+                </a:solidFill>
+                <a:latin typeface="Inter" pitchFamily="34" charset="0"/>
+                <a:ea typeface="Inter" pitchFamily="34" charset="-122"/>
+                <a:cs typeface="Inter" pitchFamily="34" charset="-120"/>
+              </a:rPr>
+              <a:t>▪ AI Voice Tutor: Deploy WebRTC connections to talk with the AI mentor.</a:t>
+            </a:r>
+            <a:pPr indent="0" marL="0">
+              <a:buNone/>
+            </a:pPr>
+            <a:r>
+              <a:rPr lang="en-US" sz="1200" dirty="0">
+                <a:solidFill>
+                  <a:srgbClr val="000000"/>
+                </a:solidFill>
+              </a:rPr>
+              <a:t>
+</a:t>
+            </a:r>
+            <a:pPr indent="0" marL="0">
+              <a:buNone/>
+            </a:pPr>
+            <a:r>
+              <a:rPr lang="en-US" sz="1300" dirty="0">
+                <a:solidFill>
+                  <a:srgbClr val="A0A0A0"/>
+                </a:solidFill>
+                <a:latin typeface="Inter" pitchFamily="34" charset="0"/>
+                <a:ea typeface="Inter" pitchFamily="34" charset="-122"/>
+                <a:cs typeface="Inter" pitchFamily="34" charset="-120"/>
+              </a:rPr>
+              <a:t>▪ Visual Learning: Generate auto-mindmaps and flowcharts directly inside explanations.</a:t>
             </a:r>
             <a:endParaRPr lang="en-US" sz="1300" dirty="0"/>
           </a:p>

</xml_diff>